<commit_message>
Update the served PowerPoint deck to the latest version
Co-Authored-By: Claude Fable 5.1 <noreply@anthropic.com>
Claude-Session: https://claude.ai/code/session_01E5kUaTdMCWkRPCSUtjW7sH
</commit_message>
<xml_diff>
--- a/public/docs/DockMaster_AI_Opportunity_Service_Writer.pptx
+++ b/public/docs/DockMaster_AI_Opportunity_Service_Writer.pptx
@@ -121,266 +121,6 @@
 </p:presentation>
 </file>
 
-<file path=ppt/charts/chart1.xml><?xml version="1.0" encoding="utf-8"?>
-<c:chartSpace xmlns:c="http://schemas.openxmlformats.org/drawingml/2006/chart" xmlns:a="http://schemas.openxmlformats.org/drawingml/2006/main" xmlns:r="http://schemas.openxmlformats.org/officeDocument/2006/relationships">
-  <c:date1904 val="0"/>
-  <c:roundedCorners val="1"/>
-  <c:chart>
-    <c:autoTitleDeleted val="1"/>
-    <c:plotArea>
-      <c:layout/>
-      <c:barChart>
-        <c:barDir val="bar"/>
-        <c:grouping val="clustered"/>
-        <c:varyColors val="0"/>
-        <c:ser>
-          <c:idx val="0"/>
-          <c:order val="0"/>
-          <c:tx>
-            <c:strRef>
-              <c:f>Sheet1!$B$1</c:f>
-              <c:strCache>
-                <c:ptCount val="1"/>
-                <c:pt idx="0">
-                  <c:v>Score</c:v>
-                </c:pt>
-              </c:strCache>
-            </c:strRef>
-          </c:tx>
-          <c:spPr>
-            <a:solidFill>
-              <a:srgbClr val="13A89E"/>
-            </a:solidFill>
-            <a:effectLst/>
-          </c:spPr>
-          <c:invertIfNegative val="0"/>
-          <c:dLbls>
-            <c:numFmt formatCode="#,##0" sourceLinked="0"/>
-            <c:txPr>
-              <a:bodyPr/>
-              <a:lstStyle/>
-              <a:p>
-                <a:pPr>
-                  <a:defRPr b="0" i="0" strike="noStrike" sz="1000" u="none">
-                    <a:solidFill>
-                      <a:srgbClr val="1B2430"/>
-                    </a:solidFill>
-                    <a:latin typeface="Arial"/>
-                  </a:defRPr>
-                </a:pPr>
-              </a:p>
-            </c:txPr>
-            <c:showLegendKey val="0"/>
-            <c:showVal val="1"/>
-            <c:showCatName val="0"/>
-            <c:showSerName val="0"/>
-            <c:showPercent val="0"/>
-            <c:showBubbleSize val="0"/>
-            <c:showLeaderLines val="0"/>
-          </c:dLbls>
-          <c:cat>
-            <c:multiLvlStrRef>
-              <c:f>Sheet1!$A$2:$A$9</c:f>
-              <c:multiLvlStrCache>
-                <c:ptCount val="8"/>
-                <c:lvl>
-                  <c:pt idx="0">
-                    <c:v>AI Service Writer</c:v>
-                  </c:pt>
-                  <c:pt idx="1">
-                    <c:v>Proactive service demand</c:v>
-                  </c:pt>
-                  <c:pt idx="2">
-                    <c:v>AR collections agent (ValPay)</c:v>
-                  </c:pt>
-                  <c:pt idx="3">
-                    <c:v>Parts demand forecasting</c:v>
-                  </c:pt>
-                  <c:pt idx="4">
-                    <c:v>Ask DockMaster reporting</c:v>
-                  </c:pt>
-                  <c:pt idx="5">
-                    <c:v>Warranty claim assembly</c:v>
-                  </c:pt>
-                  <c:pt idx="6">
-                    <c:v>Slip yield / dynamic pricing</c:v>
-                  </c:pt>
-                  <c:pt idx="7">
-                    <c:v>Boat-owner service chat</c:v>
-                  </c:pt>
-                </c:lvl>
-              </c:multiLvlStrCache>
-            </c:multiLvlStrRef>
-          </c:cat>
-          <c:val>
-            <c:numRef>
-              <c:f>Sheet1!$B$2:$B$9</c:f>
-              <c:numCache>
-                <c:formatCode>General</c:formatCode>
-                <c:ptCount val="8"/>
-                <c:pt idx="0">
-                  <c:v>24</c:v>
-                </c:pt>
-                <c:pt idx="1">
-                  <c:v>22</c:v>
-                </c:pt>
-                <c:pt idx="2">
-                  <c:v>21</c:v>
-                </c:pt>
-                <c:pt idx="3">
-                  <c:v>18</c:v>
-                </c:pt>
-                <c:pt idx="4">
-                  <c:v>17</c:v>
-                </c:pt>
-                <c:pt idx="5">
-                  <c:v>17</c:v>
-                </c:pt>
-                <c:pt idx="6">
-                  <c:v>13</c:v>
-                </c:pt>
-                <c:pt idx="7">
-                  <c:v>12</c:v>
-                </c:pt>
-              </c:numCache>
-            </c:numRef>
-          </c:val>
-        </c:ser>
-        <c:dLbls>
-          <c:numFmt formatCode="#,##0" sourceLinked="0"/>
-          <c:txPr>
-            <a:bodyPr/>
-            <a:lstStyle/>
-            <a:p>
-              <a:pPr>
-                <a:defRPr b="0" i="0" strike="noStrike" sz="1000" u="none">
-                  <a:solidFill>
-                    <a:srgbClr val="1B2430"/>
-                  </a:solidFill>
-                  <a:latin typeface="Arial"/>
-                </a:defRPr>
-              </a:pPr>
-            </a:p>
-          </c:txPr>
-          <c:showLegendKey val="0"/>
-          <c:showVal val="1"/>
-          <c:showCatName val="0"/>
-          <c:showSerName val="0"/>
-          <c:showPercent val="0"/>
-          <c:showBubbleSize val="0"/>
-          <c:showLeaderLines val="0"/>
-        </c:dLbls>
-        <c:gapWidth val="40"/>
-        <c:overlap val="0"/>
-        <c:axId val="2094734554"/>
-        <c:axId val="2094734552"/>
-        <c:axId val="2094734556"/>
-      </c:barChart>
-      <c:catAx>
-        <c:axId val="2094734554"/>
-        <c:scaling>
-          <c:orientation val="maxMin"/>
-        </c:scaling>
-        <c:delete val="0"/>
-        <c:axPos val="l"/>
-        <c:numFmt formatCode="General" sourceLinked="1"/>
-        <c:majorTickMark val="out"/>
-        <c:minorTickMark val="none"/>
-        <c:tickLblPos val="nextTo"/>
-        <c:spPr>
-          <a:ln w="12700" cap="flat">
-            <a:solidFill>
-              <a:srgbClr val="888888"/>
-            </a:solidFill>
-            <a:prstDash val="solid"/>
-            <a:round/>
-          </a:ln>
-        </c:spPr>
-        <c:txPr>
-          <a:bodyPr/>
-          <a:lstStyle/>
-          <a:p>
-            <a:pPr>
-              <a:defRPr sz="1000" b="0" i="0" u="none" strike="noStrike">
-                <a:solidFill>
-                  <a:srgbClr val="1B2430"/>
-                </a:solidFill>
-                <a:latin typeface="Arial"/>
-              </a:defRPr>
-            </a:pPr>
-            <a:endParaRPr lang="en-US"/>
-          </a:p>
-        </c:txPr>
-        <c:crossAx val="2094734552"/>
-        <c:crosses val="autoZero"/>
-        <c:auto val="1"/>
-        <c:lblAlgn val="ctr"/>
-        <c:noMultiLvlLbl val="1"/>
-      </c:catAx>
-      <c:valAx>
-        <c:axId val="2094734552"/>
-        <c:scaling>
-          <c:orientation val="minMax"/>
-          <c:max val="27"/>
-        </c:scaling>
-        <c:delete val="1"/>
-        <c:axPos val="b"/>
-        <c:numFmt formatCode="General" sourceLinked="0"/>
-        <c:majorTickMark val="out"/>
-        <c:minorTickMark val="none"/>
-        <c:tickLblPos val="low"/>
-        <c:spPr>
-          <a:ln w="12700" cap="flat">
-            <a:solidFill>
-              <a:srgbClr val="888888"/>
-            </a:solidFill>
-            <a:prstDash val="solid"/>
-            <a:round/>
-          </a:ln>
-        </c:spPr>
-        <c:txPr>
-          <a:bodyPr/>
-          <a:lstStyle/>
-          <a:p>
-            <a:pPr>
-              <a:defRPr sz="1200" b="0" i="0" u="none" strike="noStrike">
-                <a:solidFill>
-                  <a:srgbClr val="000000"/>
-                </a:solidFill>
-                <a:latin typeface="Arial"/>
-              </a:defRPr>
-            </a:pPr>
-            <a:endParaRPr lang="en-US"/>
-          </a:p>
-        </c:txPr>
-        <c:crossAx val="2094734554"/>
-        <c:crosses val="autoZero"/>
-        <c:crossBetween val="between"/>
-      </c:valAx>
-      <c:spPr>
-        <a:noFill/>
-        <a:ln>
-          <a:noFill/>
-        </a:ln>
-        <a:effectLst/>
-      </c:spPr>
-    </c:plotArea>
-    <c:plotVisOnly val="1"/>
-    <c:dispBlanksAs val="span"/>
-  </c:chart>
-  <c:spPr>
-    <a:noFill/>
-    <a:ln>
-      <a:noFill/>
-    </a:ln>
-    <a:effectLst/>
-  </c:spPr>
-  <c:externalData r:id="rId1">
-    <c:autoUpdate val="0"/>
-  </c:externalData>
-</c:chartSpace>
-</file>
-
 <file path=ppt/notesMasters/notesMaster1.xml><?xml version="1.0" encoding="utf-8"?>
 <p:notesMaster xmlns:a="http://schemas.openxmlformats.org/drawingml/2006/main" xmlns:r="http://schemas.openxmlformats.org/officeDocument/2006/relationships" xmlns:p="http://schemas.openxmlformats.org/presentationml/2006/main">
   <p:cSld>
@@ -1392,7 +1132,7 @@
           <a:p>
             <a:r>
               <a:rPr lang="en-US" dirty="0"/>
-              <a:t>Two numbers matter most. Fewer new boats plus an ageing fleet means repair and service is where marina revenue grows. And operators are squeezed on cost, so they buy labour leverage, not more seats.</a:t>
+              <a:t>Start with the asset. I am not proposing a voice agent or a scheduler; both exist. The question is what to build on top of the data they already hold.</a:t>
             </a:r>
             <a:endParaRPr lang="en-US" dirty="0"/>
           </a:p>
@@ -1480,7 +1220,7 @@
           <a:p>
             <a:r>
               <a:rPr lang="en-US" dirty="0"/>
-              <a:t>Important credibility point: I am not proposing a voice agent or a scheduler. Both exist. The gap is between the phone call and the invoice: the job itself.</a:t>
+              <a:t>Two numbers matter most: fewer new boats and more old ones. That is a service story. And cost pressure means the buyer wants leverage on labour, which is exactly what drafting from data provides.</a:t>
             </a:r>
             <a:endParaRPr lang="en-US" dirty="0"/>
           </a:p>
@@ -1568,7 +1308,7 @@
           <a:p>
             <a:r>
               <a:rPr lang="en-US" dirty="0"/>
-              <a:t/>
+              <a:t>The honest read: DockMaster wins on depth and loses on polish. An AI feature that makes the depth pay, and that requires Web, addresses both at once.</a:t>
             </a:r>
             <a:endParaRPr lang="en-US" dirty="0"/>
           </a:p>
@@ -1656,7 +1396,7 @@
           <a:p>
             <a:r>
               <a:rPr lang="en-US" dirty="0"/>
-              <a:t/>
+              <a:t>DockMaster sells to marinas, boatyards, service providers, yacht clubs, rental businesses and dealers. I am narrowing to the service-heavy yard because that is where the data is richest and the pain is measurable in dollars. Everything that follows is built for these four people.</a:t>
             </a:r>
             <a:endParaRPr lang="en-US" dirty="0"/>
           </a:p>
@@ -1744,7 +1484,7 @@
           <a:p>
             <a:r>
               <a:rPr lang="en-US" dirty="0"/>
-              <a:t>Scoring is my judgement and I would recalibrate it with account data. The ranking is robust: the top three all sit on data only DockMaster has and all measure in dollars a GM already tracks.</a:t>
+              <a:t>I scored eight candidates on customer revenue, DockMaster revenue, data moat, feasibility and fit with existing AI. These three came out on top and they share one engine and one buyer. Product one is the wedge; the other two are releases two and three.</a:t>
             </a:r>
             <a:endParaRPr lang="en-US" dirty="0"/>
           </a:p>
@@ -1832,7 +1572,7 @@
           <a:p>
             <a:r>
               <a:rPr lang="en-US" dirty="0"/>
-              <a:t>The LLM never invents an operation code, a part, a price or a vessel. It selects from the customer's own data and explains why. That is the difference between a chatbot and a service writer.</a:t>
+              <a:t>The difference between a chatbot and a service writer: the LLM never invents an operation code, a part, a price or a vessel. It selects from the customer's own data and explains why.</a:t>
             </a:r>
             <a:endParaRPr lang="en-US" dirty="0"/>
           </a:p>
@@ -8474,7 +8214,7 @@
                 <a:ea typeface="Cambria" pitchFamily="34" charset="-122"/>
                 <a:cs typeface="Cambria" pitchFamily="34" charset="-120"/>
               </a:rPr>
-              <a:t>The situation in numbers</a:t>
+              <a:t>DockMaster today</a:t>
             </a:r>
             <a:endParaRPr lang="en-US" sz="2800" dirty="0"/>
           </a:p>
@@ -8513,7 +8253,7 @@
                 <a:ea typeface="Calibri" pitchFamily="34" charset="-122"/>
                 <a:cs typeface="Calibri" pitchFamily="34" charset="-120"/>
               </a:rPr>
-              <a:t>A 40-year system of record in a market where service revenue now matters more than boat sales</a:t>
+              <a:t>A 40-year system of record for full-service marinas, with two AI features already shipped</a:t>
             </a:r>
             <a:endParaRPr lang="en-US" sz="1300" dirty="0"/>
           </a:p>
@@ -8521,18 +8261,252 @@
       </p:sp>
       <p:sp>
         <p:nvSpPr>
-          <p:cNvPr id="4" name="Shape 2"/>
+          <p:cNvPr id="4" name="Text 2"/>
+          <p:cNvSpPr txBox="1"/>
+          <p:nvPr/>
+        </p:nvSpPr>
+        <p:spPr>
+          <a:xfrm>
+            <a:off x="457200" y="1234440"/>
+            <a:ext cx="1188720" cy="411480"/>
+          </a:xfrm>
+          <a:prstGeom prst="rect">
+            <a:avLst/>
+          </a:prstGeom>
+          <a:noFill/>
+          <a:ln/>
+        </p:spPr>
+        <p:txBody>
+          <a:bodyPr wrap="square" lIns="0" tIns="0" rIns="0" bIns="0" rtlCol="0" anchor="ctr"/>
+          <a:lstStyle/>
+          <a:p>
+            <a:pPr indent="0" marL="0">
+              <a:buNone/>
+            </a:pPr>
+            <a:r>
+              <a:rPr lang="en-US" sz="2200" b="1" dirty="0">
+                <a:solidFill>
+                  <a:srgbClr val="13A89E"/>
+                </a:solidFill>
+                <a:latin typeface="Cambria" pitchFamily="34" charset="0"/>
+                <a:ea typeface="Cambria" pitchFamily="34" charset="-122"/>
+                <a:cs typeface="Cambria" pitchFamily="34" charset="-120"/>
+              </a:rPr>
+              <a:t>1,000+</a:t>
+            </a:r>
+            <a:endParaRPr lang="en-US" sz="2200" dirty="0"/>
+          </a:p>
+        </p:txBody>
+      </p:sp>
+      <p:sp>
+        <p:nvSpPr>
+          <p:cNvPr id="5" name="Text 3"/>
+          <p:cNvSpPr txBox="1"/>
+          <p:nvPr/>
+        </p:nvSpPr>
+        <p:spPr>
+          <a:xfrm>
+            <a:off x="1691640" y="1234440"/>
+            <a:ext cx="1371600" cy="411480"/>
+          </a:xfrm>
+          <a:prstGeom prst="rect">
+            <a:avLst/>
+          </a:prstGeom>
+          <a:noFill/>
+          <a:ln/>
+        </p:spPr>
+        <p:txBody>
+          <a:bodyPr wrap="square" lIns="0" tIns="0" rIns="0" bIns="0" rtlCol="0" anchor="ctr"/>
+          <a:lstStyle/>
+          <a:p>
+            <a:pPr indent="0" marL="0">
+              <a:buNone/>
+            </a:pPr>
+            <a:r>
+              <a:rPr lang="en-US" sz="1000" dirty="0">
+                <a:solidFill>
+                  <a:srgbClr val="5B6B7A"/>
+                </a:solidFill>
+                <a:latin typeface="Calibri" pitchFamily="34" charset="0"/>
+                <a:ea typeface="Calibri" pitchFamily="34" charset="-122"/>
+                <a:cs typeface="Calibri" pitchFamily="34" charset="-120"/>
+              </a:rPr>
+              <a:t>marinas, boatyards and dealers</a:t>
+            </a:r>
+            <a:endParaRPr lang="en-US" sz="1000" dirty="0"/>
+          </a:p>
+        </p:txBody>
+      </p:sp>
+      <p:sp>
+        <p:nvSpPr>
+          <p:cNvPr id="6" name="Text 4"/>
+          <p:cNvSpPr txBox="1"/>
+          <p:nvPr/>
+        </p:nvSpPr>
+        <p:spPr>
+          <a:xfrm>
+            <a:off x="3246120" y="1234440"/>
+            <a:ext cx="1188720" cy="411480"/>
+          </a:xfrm>
+          <a:prstGeom prst="rect">
+            <a:avLst/>
+          </a:prstGeom>
+          <a:noFill/>
+          <a:ln/>
+        </p:spPr>
+        <p:txBody>
+          <a:bodyPr wrap="square" lIns="0" tIns="0" rIns="0" bIns="0" rtlCol="0" anchor="ctr"/>
+          <a:lstStyle/>
+          <a:p>
+            <a:pPr indent="0" marL="0">
+              <a:buNone/>
+            </a:pPr>
+            <a:r>
+              <a:rPr lang="en-US" sz="2200" b="1" dirty="0">
+                <a:solidFill>
+                  <a:srgbClr val="13A89E"/>
+                </a:solidFill>
+                <a:latin typeface="Cambria" pitchFamily="34" charset="0"/>
+                <a:ea typeface="Cambria" pitchFamily="34" charset="-122"/>
+                <a:cs typeface="Cambria" pitchFamily="34" charset="-120"/>
+              </a:rPr>
+              <a:t>40+ yrs</a:t>
+            </a:r>
+            <a:endParaRPr lang="en-US" sz="2200" dirty="0"/>
+          </a:p>
+        </p:txBody>
+      </p:sp>
+      <p:sp>
+        <p:nvSpPr>
+          <p:cNvPr id="7" name="Text 5"/>
+          <p:cNvSpPr txBox="1"/>
+          <p:nvPr/>
+        </p:nvSpPr>
+        <p:spPr>
+          <a:xfrm>
+            <a:off x="4480560" y="1234440"/>
+            <a:ext cx="1371600" cy="411480"/>
+          </a:xfrm>
+          <a:prstGeom prst="rect">
+            <a:avLst/>
+          </a:prstGeom>
+          <a:noFill/>
+          <a:ln/>
+        </p:spPr>
+        <p:txBody>
+          <a:bodyPr wrap="square" lIns="0" tIns="0" rIns="0" bIns="0" rtlCol="0" anchor="ctr"/>
+          <a:lstStyle/>
+          <a:p>
+            <a:pPr indent="0" marL="0">
+              <a:buNone/>
+            </a:pPr>
+            <a:r>
+              <a:rPr lang="en-US" sz="1000" dirty="0">
+                <a:solidFill>
+                  <a:srgbClr val="5B6B7A"/>
+                </a:solidFill>
+                <a:latin typeface="Calibri" pitchFamily="34" charset="0"/>
+                <a:ea typeface="Calibri" pitchFamily="34" charset="-122"/>
+                <a:cs typeface="Calibri" pitchFamily="34" charset="-120"/>
+              </a:rPr>
+              <a:t>of work orders, parts and vessel history</a:t>
+            </a:r>
+            <a:endParaRPr lang="en-US" sz="1000" dirty="0"/>
+          </a:p>
+        </p:txBody>
+      </p:sp>
+      <p:sp>
+        <p:nvSpPr>
+          <p:cNvPr id="8" name="Text 6"/>
+          <p:cNvSpPr txBox="1"/>
+          <p:nvPr/>
+        </p:nvSpPr>
+        <p:spPr>
+          <a:xfrm>
+            <a:off x="6035040" y="1234440"/>
+            <a:ext cx="1188720" cy="411480"/>
+          </a:xfrm>
+          <a:prstGeom prst="rect">
+            <a:avLst/>
+          </a:prstGeom>
+          <a:noFill/>
+          <a:ln/>
+        </p:spPr>
+        <p:txBody>
+          <a:bodyPr wrap="square" lIns="0" tIns="0" rIns="0" bIns="0" rtlCol="0" anchor="ctr"/>
+          <a:lstStyle/>
+          <a:p>
+            <a:pPr indent="0" marL="0">
+              <a:buNone/>
+            </a:pPr>
+            <a:r>
+              <a:rPr lang="en-US" sz="2200" b="1" dirty="0">
+                <a:solidFill>
+                  <a:srgbClr val="13A89E"/>
+                </a:solidFill>
+                <a:latin typeface="Cambria" pitchFamily="34" charset="0"/>
+                <a:ea typeface="Cambria" pitchFamily="34" charset="-122"/>
+                <a:cs typeface="Cambria" pitchFamily="34" charset="-120"/>
+              </a:rPr>
+              <a:t>3</a:t>
+            </a:r>
+            <a:endParaRPr lang="en-US" sz="2200" dirty="0"/>
+          </a:p>
+        </p:txBody>
+      </p:sp>
+      <p:sp>
+        <p:nvSpPr>
+          <p:cNvPr id="9" name="Text 7"/>
+          <p:cNvSpPr txBox="1"/>
+          <p:nvPr/>
+        </p:nvSpPr>
+        <p:spPr>
+          <a:xfrm>
+            <a:off x="7269480" y="1234440"/>
+            <a:ext cx="1371600" cy="411480"/>
+          </a:xfrm>
+          <a:prstGeom prst="rect">
+            <a:avLst/>
+          </a:prstGeom>
+          <a:noFill/>
+          <a:ln/>
+        </p:spPr>
+        <p:txBody>
+          <a:bodyPr wrap="square" lIns="0" tIns="0" rIns="0" bIns="0" rtlCol="0" anchor="ctr"/>
+          <a:lstStyle/>
+          <a:p>
+            <a:pPr indent="0" marL="0">
+              <a:buNone/>
+            </a:pPr>
+            <a:r>
+              <a:rPr lang="en-US" sz="1000" dirty="0">
+                <a:solidFill>
+                  <a:srgbClr val="5B6B7A"/>
+                </a:solidFill>
+                <a:latin typeface="Calibri" pitchFamily="34" charset="0"/>
+                <a:ea typeface="Calibri" pitchFamily="34" charset="-122"/>
+                <a:cs typeface="Calibri" pitchFamily="34" charset="-120"/>
+              </a:rPr>
+              <a:t>surfaces: Desktop, Web 2.0 and Mobile, one dataset</a:t>
+            </a:r>
+            <a:endParaRPr lang="en-US" sz="1000" dirty="0"/>
+          </a:p>
+        </p:txBody>
+      </p:sp>
+      <p:sp>
+        <p:nvSpPr>
+          <p:cNvPr id="10" name="Shape 8"/>
           <p:cNvSpPr/>
           <p:nvPr/>
         </p:nvSpPr>
         <p:spPr>
           <a:xfrm>
-            <a:off x="457200" y="1325880"/>
-            <a:ext cx="2606040" cy="1463040"/>
+            <a:off x="457200" y="1783080"/>
+            <a:ext cx="2606040" cy="2103120"/>
           </a:xfrm>
           <a:prstGeom prst="roundRect">
             <a:avLst>
-              <a:gd name="adj" fmla="val 5000"/>
+              <a:gd name="adj" fmla="val 3478"/>
             </a:avLst>
           </a:prstGeom>
           <a:solidFill>
@@ -8546,16 +8520,40 @@
           </a:ln>
         </p:spPr>
       </p:sp>
-      <p:sp>
-        <p:nvSpPr>
-          <p:cNvPr id="5" name="Text 3"/>
-          <p:cNvSpPr txBox="1"/>
-          <p:nvPr/>
-        </p:nvSpPr>
-        <p:spPr>
-          <a:xfrm>
-            <a:off x="640080" y="1463040"/>
-            <a:ext cx="2286000" cy="640080"/>
+      <p:pic>
+        <p:nvPicPr>
+          <p:cNvPr id="11" name="Image 0" descr="preencoded.png">    </p:cNvPr>
+          <p:cNvPicPr>
+            <a:picLocks noChangeAspect="1"/>
+          </p:cNvPicPr>
+          <p:nvPr/>
+        </p:nvPicPr>
+        <p:blipFill>
+          <a:blip r:embed="rId1"/>
+          <a:stretch>
+            <a:fillRect/>
+          </a:stretch>
+        </p:blipFill>
+        <p:spPr>
+          <a:xfrm>
+            <a:off x="640080" y="1920240"/>
+            <a:ext cx="411480" cy="411480"/>
+          </a:xfrm>
+          <a:prstGeom prst="rect">
+            <a:avLst/>
+          </a:prstGeom>
+        </p:spPr>
+      </p:pic>
+      <p:sp>
+        <p:nvSpPr>
+          <p:cNvPr id="12" name="Text 9"/>
+          <p:cNvSpPr txBox="1"/>
+          <p:nvPr/>
+        </p:nvSpPr>
+        <p:spPr>
+          <a:xfrm>
+            <a:off x="1143000" y="1938528"/>
+            <a:ext cx="1828800" cy="365760"/>
           </a:xfrm>
           <a:prstGeom prst="rect">
             <a:avLst/>
@@ -8571,30 +8569,30 @@
               <a:buNone/>
             </a:pPr>
             <a:r>
-              <a:rPr lang="en-US" sz="3000" b="1" dirty="0">
-                <a:solidFill>
-                  <a:srgbClr val="13A89E"/>
+              <a:rPr lang="en-US" sz="1500" b="1" dirty="0">
+                <a:solidFill>
+                  <a:srgbClr val="0B2545"/>
                 </a:solidFill>
                 <a:latin typeface="Cambria" pitchFamily="34" charset="0"/>
                 <a:ea typeface="Cambria" pitchFamily="34" charset="-122"/>
                 <a:cs typeface="Cambria" pitchFamily="34" charset="-120"/>
               </a:rPr>
-              <a:t>1,000+</a:t>
-            </a:r>
-            <a:endParaRPr lang="en-US" sz="3000" dirty="0"/>
-          </a:p>
-        </p:txBody>
-      </p:sp>
-      <p:sp>
-        <p:nvSpPr>
-          <p:cNvPr id="6" name="Text 4"/>
-          <p:cNvSpPr txBox="1"/>
-          <p:nvPr/>
-        </p:nvSpPr>
-        <p:spPr>
-          <a:xfrm>
-            <a:off x="640080" y="2103120"/>
-            <a:ext cx="2286000" cy="594360"/>
+              <a:t>Desktop</a:t>
+            </a:r>
+            <a:endParaRPr lang="en-US" sz="1500" dirty="0"/>
+          </a:p>
+        </p:txBody>
+      </p:sp>
+      <p:sp>
+        <p:nvSpPr>
+          <p:cNvPr id="13" name="Text 10"/>
+          <p:cNvSpPr txBox="1"/>
+          <p:nvPr/>
+        </p:nvSpPr>
+        <p:spPr>
+          <a:xfrm>
+            <a:off x="640080" y="2423160"/>
+            <a:ext cx="2286000" cy="1371600"/>
           </a:xfrm>
           <a:prstGeom prst="rect">
             <a:avLst/>
@@ -8610,7 +8608,7 @@
               <a:buNone/>
             </a:pPr>
             <a:r>
-              <a:rPr lang="en-US" sz="1150" dirty="0">
+              <a:rPr lang="en-US" sz="1050" dirty="0">
                 <a:solidFill>
                   <a:srgbClr val="1B2430"/>
                 </a:solidFill>
@@ -8618,26 +8616,26 @@
                 <a:ea typeface="Calibri" pitchFamily="34" charset="-122"/>
                 <a:cs typeface="Calibri" pitchFamily="34" charset="-120"/>
               </a:rPr>
-              <a:t>marinas, boatyards and dealers on DockMaster</a:t>
-            </a:r>
-            <a:endParaRPr lang="en-US" sz="1150" dirty="0"/>
-          </a:p>
-        </p:txBody>
-      </p:sp>
-      <p:sp>
-        <p:nvSpPr>
-          <p:cNvPr id="7" name="Shape 5"/>
+              <a:t>The ERP backbone. Slips, dry stack, service, inventory, boat sales, POS and full accounting. A move to SQL is on the 2026 roadmap.</a:t>
+            </a:r>
+            <a:endParaRPr lang="en-US" sz="1050" dirty="0"/>
+          </a:p>
+        </p:txBody>
+      </p:sp>
+      <p:sp>
+        <p:nvSpPr>
+          <p:cNvPr id="14" name="Shape 11"/>
           <p:cNvSpPr/>
           <p:nvPr/>
         </p:nvSpPr>
         <p:spPr>
           <a:xfrm>
-            <a:off x="3246120" y="1325880"/>
-            <a:ext cx="2606040" cy="1463040"/>
+            <a:off x="3246120" y="1783080"/>
+            <a:ext cx="2606040" cy="2103120"/>
           </a:xfrm>
           <a:prstGeom prst="roundRect">
             <a:avLst>
-              <a:gd name="adj" fmla="val 5000"/>
+              <a:gd name="adj" fmla="val 3478"/>
             </a:avLst>
           </a:prstGeom>
           <a:solidFill>
@@ -8651,16 +8649,40 @@
           </a:ln>
         </p:spPr>
       </p:sp>
-      <p:sp>
-        <p:nvSpPr>
-          <p:cNvPr id="8" name="Text 6"/>
-          <p:cNvSpPr txBox="1"/>
-          <p:nvPr/>
-        </p:nvSpPr>
-        <p:spPr>
-          <a:xfrm>
-            <a:off x="3429000" y="1463040"/>
-            <a:ext cx="2286000" cy="640080"/>
+      <p:pic>
+        <p:nvPicPr>
+          <p:cNvPr id="15" name="Image 1" descr="preencoded.png">    </p:cNvPr>
+          <p:cNvPicPr>
+            <a:picLocks noChangeAspect="1"/>
+          </p:cNvPicPr>
+          <p:nvPr/>
+        </p:nvPicPr>
+        <p:blipFill>
+          <a:blip r:embed="rId2"/>
+          <a:stretch>
+            <a:fillRect/>
+          </a:stretch>
+        </p:blipFill>
+        <p:spPr>
+          <a:xfrm>
+            <a:off x="3429000" y="1920240"/>
+            <a:ext cx="411480" cy="411480"/>
+          </a:xfrm>
+          <a:prstGeom prst="rect">
+            <a:avLst/>
+          </a:prstGeom>
+        </p:spPr>
+      </p:pic>
+      <p:sp>
+        <p:nvSpPr>
+          <p:cNvPr id="16" name="Text 12"/>
+          <p:cNvSpPr txBox="1"/>
+          <p:nvPr/>
+        </p:nvSpPr>
+        <p:spPr>
+          <a:xfrm>
+            <a:off x="3931920" y="1938528"/>
+            <a:ext cx="1828800" cy="365760"/>
           </a:xfrm>
           <a:prstGeom prst="rect">
             <a:avLst/>
@@ -8676,30 +8698,30 @@
               <a:buNone/>
             </a:pPr>
             <a:r>
-              <a:rPr lang="en-US" sz="3000" b="1" dirty="0">
-                <a:solidFill>
-                  <a:srgbClr val="13A89E"/>
+              <a:rPr lang="en-US" sz="1500" b="1" dirty="0">
+                <a:solidFill>
+                  <a:srgbClr val="0B2545"/>
                 </a:solidFill>
                 <a:latin typeface="Cambria" pitchFamily="34" charset="0"/>
                 <a:ea typeface="Cambria" pitchFamily="34" charset="-122"/>
                 <a:cs typeface="Cambria" pitchFamily="34" charset="-120"/>
               </a:rPr>
-              <a:t>40+ yrs</a:t>
-            </a:r>
-            <a:endParaRPr lang="en-US" sz="3000" dirty="0"/>
-          </a:p>
-        </p:txBody>
-      </p:sp>
-      <p:sp>
-        <p:nvSpPr>
-          <p:cNvPr id="9" name="Text 7"/>
-          <p:cNvSpPr txBox="1"/>
-          <p:nvPr/>
-        </p:nvSpPr>
-        <p:spPr>
-          <a:xfrm>
-            <a:off x="3429000" y="2103120"/>
-            <a:ext cx="2286000" cy="594360"/>
+              <a:t>Web 2.0 and Mobile</a:t>
+            </a:r>
+            <a:endParaRPr lang="en-US" sz="1500" dirty="0"/>
+          </a:p>
+        </p:txBody>
+      </p:sp>
+      <p:sp>
+        <p:nvSpPr>
+          <p:cNvPr id="17" name="Text 13"/>
+          <p:cNvSpPr txBox="1"/>
+          <p:nvPr/>
+        </p:nvSpPr>
+        <p:spPr>
+          <a:xfrm>
+            <a:off x="3429000" y="2423160"/>
+            <a:ext cx="2286000" cy="1371600"/>
           </a:xfrm>
           <a:prstGeom prst="rect">
             <a:avLst/>
@@ -8715,7 +8737,7 @@
               <a:buNone/>
             </a:pPr>
             <a:r>
-              <a:rPr lang="en-US" sz="1150" dirty="0">
+              <a:rPr lang="en-US" sz="1050" dirty="0">
                 <a:solidFill>
                   <a:srgbClr val="1B2430"/>
                 </a:solidFill>
@@ -8723,26 +8745,26 @@
                 <a:ea typeface="Calibri" pitchFamily="34" charset="-122"/>
                 <a:cs typeface="Calibri" pitchFamily="34" charset="-120"/>
               </a:rPr>
-              <a:t>of structured work orders, parts and vessel history</a:t>
-            </a:r>
-            <a:endParaRPr lang="en-US" sz="1150" dirty="0"/>
-          </a:p>
-        </p:txBody>
-      </p:sp>
-      <p:sp>
-        <p:nvSpPr>
-          <p:cNvPr id="10" name="Shape 8"/>
+              <a:t>CRM, customer portal, estimates and work orders, drag-and-drop scheduling, eSignature, payments via ValPay. Offline-first tech app with voice notes and photos.</a:t>
+            </a:r>
+            <a:endParaRPr lang="en-US" sz="1050" dirty="0"/>
+          </a:p>
+        </p:txBody>
+      </p:sp>
+      <p:sp>
+        <p:nvSpPr>
+          <p:cNvPr id="18" name="Shape 14"/>
           <p:cNvSpPr/>
           <p:nvPr/>
         </p:nvSpPr>
         <p:spPr>
           <a:xfrm>
-            <a:off x="6035040" y="1325880"/>
-            <a:ext cx="2606040" cy="1463040"/>
+            <a:off x="6035040" y="1783080"/>
+            <a:ext cx="2606040" cy="2103120"/>
           </a:xfrm>
           <a:prstGeom prst="roundRect">
             <a:avLst>
-              <a:gd name="adj" fmla="val 5000"/>
+              <a:gd name="adj" fmla="val 3478"/>
             </a:avLst>
           </a:prstGeom>
           <a:solidFill>
@@ -8756,16 +8778,40 @@
           </a:ln>
         </p:spPr>
       </p:sp>
-      <p:sp>
-        <p:nvSpPr>
-          <p:cNvPr id="11" name="Text 9"/>
-          <p:cNvSpPr txBox="1"/>
-          <p:nvPr/>
-        </p:nvSpPr>
-        <p:spPr>
-          <a:xfrm>
-            <a:off x="6217920" y="1463040"/>
-            <a:ext cx="2286000" cy="640080"/>
+      <p:pic>
+        <p:nvPicPr>
+          <p:cNvPr id="19" name="Image 2" descr="preencoded.png">    </p:cNvPr>
+          <p:cNvPicPr>
+            <a:picLocks noChangeAspect="1"/>
+          </p:cNvPicPr>
+          <p:nvPr/>
+        </p:nvPicPr>
+        <p:blipFill>
+          <a:blip r:embed="rId3"/>
+          <a:stretch>
+            <a:fillRect/>
+          </a:stretch>
+        </p:blipFill>
+        <p:spPr>
+          <a:xfrm>
+            <a:off x="6217920" y="1920240"/>
+            <a:ext cx="411480" cy="411480"/>
+          </a:xfrm>
+          <a:prstGeom prst="rect">
+            <a:avLst/>
+          </a:prstGeom>
+        </p:spPr>
+      </p:pic>
+      <p:sp>
+        <p:nvSpPr>
+          <p:cNvPr id="20" name="Text 15"/>
+          <p:cNvSpPr txBox="1"/>
+          <p:nvPr/>
+        </p:nvSpPr>
+        <p:spPr>
+          <a:xfrm>
+            <a:off x="6720840" y="1938528"/>
+            <a:ext cx="1828800" cy="365760"/>
           </a:xfrm>
           <a:prstGeom prst="rect">
             <a:avLst/>
@@ -8781,30 +8827,30 @@
               <a:buNone/>
             </a:pPr>
             <a:r>
-              <a:rPr lang="en-US" sz="3000" b="1" dirty="0">
-                <a:solidFill>
-                  <a:srgbClr val="13A89E"/>
+              <a:rPr lang="en-US" sz="1500" b="1" dirty="0">
+                <a:solidFill>
+                  <a:srgbClr val="0B2545"/>
                 </a:solidFill>
                 <a:latin typeface="Cambria" pitchFamily="34" charset="0"/>
                 <a:ea typeface="Cambria" pitchFamily="34" charset="-122"/>
                 <a:cs typeface="Cambria" pitchFamily="34" charset="-120"/>
               </a:rPr>
-              <a:t>10-12k</a:t>
-            </a:r>
-            <a:endParaRPr lang="en-US" sz="3000" dirty="0"/>
-          </a:p>
-        </p:txBody>
-      </p:sp>
-      <p:sp>
-        <p:nvSpPr>
-          <p:cNvPr id="12" name="Text 10"/>
-          <p:cNvSpPr txBox="1"/>
-          <p:nvPr/>
-        </p:nvSpPr>
-        <p:spPr>
-          <a:xfrm>
-            <a:off x="6217920" y="2103120"/>
-            <a:ext cx="2286000" cy="594360"/>
+              <a:t>AI shipped</a:t>
+            </a:r>
+            <a:endParaRPr lang="en-US" sz="1500" dirty="0"/>
+          </a:p>
+        </p:txBody>
+      </p:sp>
+      <p:sp>
+        <p:nvSpPr>
+          <p:cNvPr id="21" name="Text 16"/>
+          <p:cNvSpPr txBox="1"/>
+          <p:nvPr/>
+        </p:nvSpPr>
+        <p:spPr>
+          <a:xfrm>
+            <a:off x="6217920" y="2423160"/>
+            <a:ext cx="2286000" cy="1371600"/>
           </a:xfrm>
           <a:prstGeom prst="rect">
             <a:avLst/>
@@ -8820,7 +8866,7 @@
               <a:buNone/>
             </a:pPr>
             <a:r>
-              <a:rPr lang="en-US" sz="1150" dirty="0">
+              <a:rPr lang="en-US" sz="1050" dirty="0">
                 <a:solidFill>
                   <a:srgbClr val="1B2430"/>
                 </a:solidFill>
@@ -8828,34 +8874,34 @@
                 <a:ea typeface="Calibri" pitchFamily="34" charset="-122"/>
                 <a:cs typeface="Calibri" pitchFamily="34" charset="-120"/>
               </a:rPr>
-              <a:t>US marinas in the addressable market</a:t>
-            </a:r>
-            <a:endParaRPr lang="en-US" sz="1150" dirty="0"/>
-          </a:p>
-        </p:txBody>
-      </p:sp>
-      <p:sp>
-        <p:nvSpPr>
-          <p:cNvPr id="13" name="Shape 11"/>
+              <a:t>AI Scheduling Assistant recommends technician slots; staff accept or reject. Blu Voice Agent (BluSynq) answers calls, quotes and books 24/7.</a:t>
+            </a:r>
+            <a:endParaRPr lang="en-US" sz="1050" dirty="0"/>
+          </a:p>
+        </p:txBody>
+      </p:sp>
+      <p:sp>
+        <p:nvSpPr>
+          <p:cNvPr id="22" name="Shape 17"/>
           <p:cNvSpPr/>
           <p:nvPr/>
         </p:nvSpPr>
         <p:spPr>
           <a:xfrm>
-            <a:off x="457200" y="2971800"/>
-            <a:ext cx="2606040" cy="1463040"/>
+            <a:off x="457200" y="4023360"/>
+            <a:ext cx="8229600" cy="594360"/>
           </a:xfrm>
           <a:prstGeom prst="roundRect">
             <a:avLst>
-              <a:gd name="adj" fmla="val 5000"/>
+              <a:gd name="adj" fmla="val 12308"/>
             </a:avLst>
           </a:prstGeom>
           <a:solidFill>
-            <a:srgbClr val="F3F6F8"/>
+            <a:srgbClr val="E3F5F3"/>
           </a:solidFill>
           <a:ln w="6350">
             <a:solidFill>
-              <a:srgbClr val="F3F6F8"/>
+              <a:srgbClr val="E3F5F3"/>
             </a:solidFill>
             <a:prstDash val="solid"/>
           </a:ln>
@@ -8863,14 +8909,14 @@
       </p:sp>
       <p:sp>
         <p:nvSpPr>
-          <p:cNvPr id="14" name="Text 12"/>
-          <p:cNvSpPr txBox="1"/>
-          <p:nvPr/>
-        </p:nvSpPr>
-        <p:spPr>
-          <a:xfrm>
-            <a:off x="640080" y="3108960"/>
-            <a:ext cx="2286000" cy="640080"/>
+          <p:cNvPr id="23" name="Text 18"/>
+          <p:cNvSpPr txBox="1"/>
+          <p:nvPr/>
+        </p:nvSpPr>
+        <p:spPr>
+          <a:xfrm>
+            <a:off x="640080" y="4069080"/>
+            <a:ext cx="7863840" cy="502920"/>
           </a:xfrm>
           <a:prstGeom prst="rect">
             <a:avLst/>
@@ -8886,151 +8932,21 @@
               <a:buNone/>
             </a:pPr>
             <a:r>
-              <a:rPr lang="en-US" sz="3000" b="1" dirty="0">
-                <a:solidFill>
-                  <a:srgbClr val="13A89E"/>
-                </a:solidFill>
-                <a:latin typeface="Cambria" pitchFamily="34" charset="0"/>
-                <a:ea typeface="Cambria" pitchFamily="34" charset="-122"/>
-                <a:cs typeface="Cambria" pitchFamily="34" charset="-120"/>
-              </a:rPr>
-              <a:t>$7.6B</a:t>
-            </a:r>
-            <a:endParaRPr lang="en-US" sz="3000" dirty="0"/>
-          </a:p>
-        </p:txBody>
-      </p:sp>
-      <p:sp>
-        <p:nvSpPr>
-          <p:cNvPr id="15" name="Text 13"/>
-          <p:cNvSpPr txBox="1"/>
-          <p:nvPr/>
-        </p:nvSpPr>
-        <p:spPr>
-          <a:xfrm>
-            <a:off x="640080" y="3749040"/>
-            <a:ext cx="2286000" cy="594360"/>
-          </a:xfrm>
-          <a:prstGeom prst="rect">
-            <a:avLst/>
-          </a:prstGeom>
-          <a:noFill/>
-          <a:ln/>
-        </p:spPr>
-        <p:txBody>
-          <a:bodyPr wrap="square" lIns="0" tIns="0" rIns="0" bIns="0" rtlCol="0" anchor="t"/>
-          <a:lstStyle/>
-          <a:p>
-            <a:pPr indent="0" marL="0">
-              <a:buNone/>
-            </a:pPr>
-            <a:r>
-              <a:rPr lang="en-US" sz="1150" dirty="0">
-                <a:solidFill>
-                  <a:srgbClr val="1B2430"/>
+              <a:rPr lang="en-US" sz="1100" b="1" dirty="0">
+                <a:solidFill>
+                  <a:srgbClr val="0B2545"/>
                 </a:solidFill>
                 <a:latin typeface="Calibri" pitchFamily="34" charset="0"/>
                 <a:ea typeface="Calibri" pitchFamily="34" charset="-122"/>
                 <a:cs typeface="Calibri" pitchFamily="34" charset="-120"/>
               </a:rPr>
-              <a:t>US marina industry revenue (2025)</a:t>
-            </a:r>
-            <a:endParaRPr lang="en-US" sz="1150" dirty="0"/>
-          </a:p>
-        </p:txBody>
-      </p:sp>
-      <p:sp>
-        <p:nvSpPr>
-          <p:cNvPr id="16" name="Shape 14"/>
-          <p:cNvSpPr/>
-          <p:nvPr/>
-        </p:nvSpPr>
-        <p:spPr>
-          <a:xfrm>
-            <a:off x="3246120" y="2971800"/>
-            <a:ext cx="2606040" cy="1463040"/>
-          </a:xfrm>
-          <a:prstGeom prst="roundRect">
-            <a:avLst>
-              <a:gd name="adj" fmla="val 5000"/>
-            </a:avLst>
-          </a:prstGeom>
-          <a:solidFill>
-            <a:srgbClr val="F3F6F8"/>
-          </a:solidFill>
-          <a:ln w="6350">
-            <a:solidFill>
-              <a:srgbClr val="F3F6F8"/>
-            </a:solidFill>
-            <a:prstDash val="solid"/>
-          </a:ln>
-        </p:spPr>
-      </p:sp>
-      <p:sp>
-        <p:nvSpPr>
-          <p:cNvPr id="17" name="Text 15"/>
-          <p:cNvSpPr txBox="1"/>
-          <p:nvPr/>
-        </p:nvSpPr>
-        <p:spPr>
-          <a:xfrm>
-            <a:off x="3429000" y="3108960"/>
-            <a:ext cx="2286000" cy="640080"/>
-          </a:xfrm>
-          <a:prstGeom prst="rect">
-            <a:avLst/>
-          </a:prstGeom>
-          <a:noFill/>
-          <a:ln/>
-        </p:spPr>
-        <p:txBody>
-          <a:bodyPr wrap="square" lIns="0" tIns="0" rIns="0" bIns="0" rtlCol="0" anchor="ctr"/>
-          <a:lstStyle/>
-          <a:p>
+              <a:t>The asset: </a:t>
+            </a:r>
             <a:pPr indent="0" marL="0">
               <a:buNone/>
             </a:pPr>
             <a:r>
-              <a:rPr lang="en-US" sz="3000" b="1" dirty="0">
-                <a:solidFill>
-                  <a:srgbClr val="13A89E"/>
-                </a:solidFill>
-                <a:latin typeface="Cambria" pitchFamily="34" charset="0"/>
-                <a:ea typeface="Cambria" pitchFamily="34" charset="-122"/>
-                <a:cs typeface="Cambria" pitchFamily="34" charset="-120"/>
-              </a:rPr>
-              <a:t>-8 to -10%</a:t>
-            </a:r>
-            <a:endParaRPr lang="en-US" sz="3000" dirty="0"/>
-          </a:p>
-        </p:txBody>
-      </p:sp>
-      <p:sp>
-        <p:nvSpPr>
-          <p:cNvPr id="18" name="Text 16"/>
-          <p:cNvSpPr txBox="1"/>
-          <p:nvPr/>
-        </p:nvSpPr>
-        <p:spPr>
-          <a:xfrm>
-            <a:off x="3429000" y="3749040"/>
-            <a:ext cx="2286000" cy="594360"/>
-          </a:xfrm>
-          <a:prstGeom prst="rect">
-            <a:avLst/>
-          </a:prstGeom>
-          <a:noFill/>
-          <a:ln/>
-        </p:spPr>
-        <p:txBody>
-          <a:bodyPr wrap="square" lIns="0" tIns="0" rIns="0" bIns="0" rtlCol="0" anchor="t"/>
-          <a:lstStyle/>
-          <a:p>
-            <a:pPr indent="0" marL="0">
-              <a:buNone/>
-            </a:pPr>
-            <a:r>
-              <a:rPr lang="en-US" sz="1150" dirty="0">
+              <a:rPr lang="en-US" sz="1100" dirty="0">
                 <a:solidFill>
                   <a:srgbClr val="1B2430"/>
                 </a:solidFill>
@@ -9038,159 +8954,15 @@
                 <a:ea typeface="Calibri" pitchFamily="34" charset="-122"/>
                 <a:cs typeface="Calibri" pitchFamily="34" charset="-120"/>
               </a:rPr>
-              <a:t>new powerboat retail sales, 2025</a:t>
-            </a:r>
-            <a:endParaRPr lang="en-US" sz="1150" dirty="0"/>
-          </a:p>
-        </p:txBody>
-      </p:sp>
-      <p:sp>
-        <p:nvSpPr>
-          <p:cNvPr id="19" name="Shape 17"/>
-          <p:cNvSpPr/>
-          <p:nvPr/>
-        </p:nvSpPr>
-        <p:spPr>
-          <a:xfrm>
-            <a:off x="6035040" y="2971800"/>
-            <a:ext cx="2606040" cy="1463040"/>
-          </a:xfrm>
-          <a:prstGeom prst="roundRect">
-            <a:avLst>
-              <a:gd name="adj" fmla="val 5000"/>
-            </a:avLst>
-          </a:prstGeom>
-          <a:solidFill>
-            <a:srgbClr val="F3F6F8"/>
-          </a:solidFill>
-          <a:ln w="6350">
-            <a:solidFill>
-              <a:srgbClr val="F3F6F8"/>
-            </a:solidFill>
-            <a:prstDash val="solid"/>
-          </a:ln>
-        </p:spPr>
-      </p:sp>
-      <p:sp>
-        <p:nvSpPr>
-          <p:cNvPr id="20" name="Text 18"/>
-          <p:cNvSpPr txBox="1"/>
-          <p:nvPr/>
-        </p:nvSpPr>
-        <p:spPr>
-          <a:xfrm>
-            <a:off x="6217920" y="3108960"/>
-            <a:ext cx="2286000" cy="640080"/>
-          </a:xfrm>
-          <a:prstGeom prst="rect">
-            <a:avLst/>
-          </a:prstGeom>
-          <a:noFill/>
-          <a:ln/>
-        </p:spPr>
-        <p:txBody>
-          <a:bodyPr wrap="square" lIns="0" tIns="0" rIns="0" bIns="0" rtlCol="0" anchor="ctr"/>
-          <a:lstStyle/>
-          <a:p>
-            <a:pPr indent="0" marL="0">
-              <a:buNone/>
-            </a:pPr>
-            <a:r>
-              <a:rPr lang="en-US" sz="3000" b="1" dirty="0">
-                <a:solidFill>
-                  <a:srgbClr val="13A89E"/>
-                </a:solidFill>
-                <a:latin typeface="Cambria" pitchFamily="34" charset="0"/>
-                <a:ea typeface="Cambria" pitchFamily="34" charset="-122"/>
-                <a:cs typeface="Cambria" pitchFamily="34" charset="-120"/>
-              </a:rPr>
-              <a:t>73%</a:t>
-            </a:r>
-            <a:endParaRPr lang="en-US" sz="3000" dirty="0"/>
-          </a:p>
-        </p:txBody>
-      </p:sp>
-      <p:sp>
-        <p:nvSpPr>
-          <p:cNvPr id="21" name="Text 19"/>
-          <p:cNvSpPr txBox="1"/>
-          <p:nvPr/>
-        </p:nvSpPr>
-        <p:spPr>
-          <a:xfrm>
-            <a:off x="6217920" y="3749040"/>
-            <a:ext cx="2286000" cy="594360"/>
-          </a:xfrm>
-          <a:prstGeom prst="rect">
-            <a:avLst/>
-          </a:prstGeom>
-          <a:noFill/>
-          <a:ln/>
-        </p:spPr>
-        <p:txBody>
-          <a:bodyPr wrap="square" lIns="0" tIns="0" rIns="0" bIns="0" rtlCol="0" anchor="t"/>
-          <a:lstStyle/>
-          <a:p>
-            <a:pPr indent="0" marL="0">
-              <a:buNone/>
-            </a:pPr>
-            <a:r>
-              <a:rPr lang="en-US" sz="1150" dirty="0">
-                <a:solidFill>
-                  <a:srgbClr val="1B2430"/>
-                </a:solidFill>
-                <a:latin typeface="Calibri" pitchFamily="34" charset="0"/>
-                <a:ea typeface="Calibri" pitchFamily="34" charset="-122"/>
-                <a:cs typeface="Calibri" pitchFamily="34" charset="-120"/>
-              </a:rPr>
-              <a:t>of marinas report insurance costs up; 67% staffing costs up</a:t>
-            </a:r>
-            <a:endParaRPr lang="en-US" sz="1150" dirty="0"/>
-          </a:p>
-        </p:txBody>
-      </p:sp>
-      <p:sp>
-        <p:nvSpPr>
-          <p:cNvPr id="22" name="Text 20"/>
-          <p:cNvSpPr txBox="1"/>
-          <p:nvPr/>
-        </p:nvSpPr>
-        <p:spPr>
-          <a:xfrm>
-            <a:off x="457200" y="4572000"/>
-            <a:ext cx="8229600" cy="228600"/>
-          </a:xfrm>
-          <a:prstGeom prst="rect">
-            <a:avLst/>
-          </a:prstGeom>
-          <a:noFill/>
-          <a:ln/>
-        </p:spPr>
-        <p:txBody>
-          <a:bodyPr wrap="square" lIns="0" tIns="0" rIns="0" bIns="0" rtlCol="0" anchor="ctr"/>
-          <a:lstStyle/>
-          <a:p>
-            <a:pPr indent="0" marL="0">
-              <a:buNone/>
-            </a:pPr>
-            <a:r>
-              <a:rPr lang="en-US" sz="800" dirty="0">
-                <a:solidFill>
-                  <a:srgbClr val="9AA6B2"/>
-                </a:solidFill>
-                <a:latin typeface="Calibri" pitchFamily="34" charset="0"/>
-                <a:ea typeface="Calibri" pitchFamily="34" charset="-122"/>
-                <a:cs typeface="Calibri" pitchFamily="34" charset="-120"/>
-              </a:rPr>
-              <a:t>Sources: dockmaster.com; Marina Dock Age 2025 survey; IBISWorld; Marina World Jul 2026; NMMA via Vertical IQ</a:t>
-            </a:r>
-            <a:endParaRPr lang="en-US" sz="800" dirty="0"/>
-          </a:p>
-        </p:txBody>
-      </p:sp>
-      <p:sp>
-        <p:nvSpPr>
-          <p:cNvPr id="23" name="Text 21"/>
+              <a:t>nobody else holds decades of operation codes, labour standards, parts usage and vessel histories for full-service yards. New AI should be built on that data and hand off to the scheduler and to Blu, not duplicate them.</a:t>
+            </a:r>
+            <a:endParaRPr lang="en-US" sz="1100" dirty="0"/>
+          </a:p>
+        </p:txBody>
+      </p:sp>
+      <p:sp>
+        <p:nvSpPr>
+          <p:cNvPr id="24" name="Text 19"/>
           <p:cNvSpPr txBox="1"/>
           <p:nvPr/>
         </p:nvSpPr>
@@ -9285,7 +9057,7 @@
                 <a:ea typeface="Cambria" pitchFamily="34" charset="-122"/>
                 <a:cs typeface="Cambria" pitchFamily="34" charset="-120"/>
               </a:rPr>
-              <a:t>What DockMaster already has</a:t>
+              <a:t>The market is moving toward service revenue</a:t>
             </a:r>
             <a:endParaRPr lang="en-US" sz="2800" dirty="0"/>
           </a:p>
@@ -9324,7 +9096,7 @@
                 <a:ea typeface="Calibri" pitchFamily="34" charset="-122"/>
                 <a:cs typeface="Calibri" pitchFamily="34" charset="-120"/>
               </a:rPr>
-              <a:t>Three surfaces, one dataset, and two AI features already shipped. We build on them, not over them.</a:t>
+              <a:t>Fewer new boats, an ageing fleet and rising costs push marina profit into the repair shop</a:t>
             </a:r>
             <a:endParaRPr lang="en-US" sz="1300" dirty="0"/>
           </a:p>
@@ -9339,11 +9111,11 @@
         <p:spPr>
           <a:xfrm>
             <a:off x="457200" y="1325880"/>
-            <a:ext cx="2606040" cy="2468880"/>
+            <a:ext cx="2423160" cy="1463040"/>
           </a:xfrm>
           <a:prstGeom prst="roundRect">
             <a:avLst>
-              <a:gd name="adj" fmla="val 2963"/>
+              <a:gd name="adj" fmla="val 5000"/>
             </a:avLst>
           </a:prstGeom>
           <a:solidFill>
@@ -9357,40 +9129,16 @@
           </a:ln>
         </p:spPr>
       </p:sp>
-      <p:pic>
-        <p:nvPicPr>
-          <p:cNvPr id="5" name="Image 0" descr="preencoded.png">    </p:cNvPr>
-          <p:cNvPicPr>
-            <a:picLocks noChangeAspect="1"/>
-          </p:cNvPicPr>
-          <p:nvPr/>
-        </p:nvPicPr>
-        <p:blipFill>
-          <a:blip r:embed="rId1"/>
-          <a:stretch>
-            <a:fillRect/>
-          </a:stretch>
-        </p:blipFill>
-        <p:spPr>
-          <a:xfrm>
-            <a:off x="640080" y="1508760"/>
-            <a:ext cx="457200" cy="457200"/>
-          </a:xfrm>
-          <a:prstGeom prst="rect">
-            <a:avLst/>
-          </a:prstGeom>
-        </p:spPr>
-      </p:pic>
-      <p:sp>
-        <p:nvSpPr>
-          <p:cNvPr id="6" name="Text 3"/>
-          <p:cNvSpPr txBox="1"/>
-          <p:nvPr/>
-        </p:nvSpPr>
-        <p:spPr>
-          <a:xfrm>
-            <a:off x="640080" y="2057400"/>
-            <a:ext cx="2286000" cy="320040"/>
+      <p:sp>
+        <p:nvSpPr>
+          <p:cNvPr id="5" name="Text 3"/>
+          <p:cNvSpPr txBox="1"/>
+          <p:nvPr/>
+        </p:nvSpPr>
+        <p:spPr>
+          <a:xfrm>
+            <a:off x="640080" y="1463040"/>
+            <a:ext cx="2103120" cy="640080"/>
           </a:xfrm>
           <a:prstGeom prst="rect">
             <a:avLst/>
@@ -9406,30 +9154,30 @@
               <a:buNone/>
             </a:pPr>
             <a:r>
-              <a:rPr lang="en-US" sz="1600" b="1" dirty="0">
-                <a:solidFill>
-                  <a:srgbClr val="0B2545"/>
+              <a:rPr lang="en-US" sz="2800" b="1" dirty="0">
+                <a:solidFill>
+                  <a:srgbClr val="13A89E"/>
                 </a:solidFill>
                 <a:latin typeface="Cambria" pitchFamily="34" charset="0"/>
                 <a:ea typeface="Cambria" pitchFamily="34" charset="-122"/>
                 <a:cs typeface="Cambria" pitchFamily="34" charset="-120"/>
               </a:rPr>
-              <a:t>Desktop</a:t>
-            </a:r>
-            <a:endParaRPr lang="en-US" sz="1600" dirty="0"/>
-          </a:p>
-        </p:txBody>
-      </p:sp>
-      <p:sp>
-        <p:nvSpPr>
-          <p:cNvPr id="7" name="Text 4"/>
-          <p:cNvSpPr txBox="1"/>
-          <p:nvPr/>
-        </p:nvSpPr>
-        <p:spPr>
-          <a:xfrm>
-            <a:off x="640080" y="2395728"/>
-            <a:ext cx="2286000" cy="1325880"/>
+              <a:t>10-12k</a:t>
+            </a:r>
+            <a:endParaRPr lang="en-US" sz="2800" dirty="0"/>
+          </a:p>
+        </p:txBody>
+      </p:sp>
+      <p:sp>
+        <p:nvSpPr>
+          <p:cNvPr id="6" name="Text 4"/>
+          <p:cNvSpPr txBox="1"/>
+          <p:nvPr/>
+        </p:nvSpPr>
+        <p:spPr>
+          <a:xfrm>
+            <a:off x="640080" y="2103120"/>
+            <a:ext cx="2103120" cy="594360"/>
           </a:xfrm>
           <a:prstGeom prst="rect">
             <a:avLst/>
@@ -9453,7 +9201,7 @@
                 <a:ea typeface="Calibri" pitchFamily="34" charset="-122"/>
                 <a:cs typeface="Calibri" pitchFamily="34" charset="-120"/>
               </a:rPr>
-              <a:t>The ERP backbone. Slips, dry stack, service, inventory, boat sales, POS and full accounting. A move to SQL is on the 2026 roadmap.</a:t>
+              <a:t>US marinas; $7.6B industry revenue (2025)</a:t>
             </a:r>
             <a:endParaRPr lang="en-US" sz="1100" dirty="0"/>
           </a:p>
@@ -9461,18 +9209,18 @@
       </p:sp>
       <p:sp>
         <p:nvSpPr>
-          <p:cNvPr id="8" name="Shape 5"/>
+          <p:cNvPr id="7" name="Shape 5"/>
           <p:cNvSpPr/>
           <p:nvPr/>
         </p:nvSpPr>
         <p:spPr>
           <a:xfrm>
-            <a:off x="3246120" y="1325880"/>
-            <a:ext cx="2606040" cy="2468880"/>
+            <a:off x="3063240" y="1325880"/>
+            <a:ext cx="2423160" cy="1463040"/>
           </a:xfrm>
           <a:prstGeom prst="roundRect">
             <a:avLst>
-              <a:gd name="adj" fmla="val 2963"/>
+              <a:gd name="adj" fmla="val 5000"/>
             </a:avLst>
           </a:prstGeom>
           <a:solidFill>
@@ -9486,40 +9234,16 @@
           </a:ln>
         </p:spPr>
       </p:sp>
-      <p:pic>
-        <p:nvPicPr>
-          <p:cNvPr id="9" name="Image 1" descr="preencoded.png">    </p:cNvPr>
-          <p:cNvPicPr>
-            <a:picLocks noChangeAspect="1"/>
-          </p:cNvPicPr>
-          <p:nvPr/>
-        </p:nvPicPr>
-        <p:blipFill>
-          <a:blip r:embed="rId2"/>
-          <a:stretch>
-            <a:fillRect/>
-          </a:stretch>
-        </p:blipFill>
-        <p:spPr>
-          <a:xfrm>
-            <a:off x="3429000" y="1508760"/>
-            <a:ext cx="457200" cy="457200"/>
-          </a:xfrm>
-          <a:prstGeom prst="rect">
-            <a:avLst/>
-          </a:prstGeom>
-        </p:spPr>
-      </p:pic>
-      <p:sp>
-        <p:nvSpPr>
-          <p:cNvPr id="10" name="Text 6"/>
-          <p:cNvSpPr txBox="1"/>
-          <p:nvPr/>
-        </p:nvSpPr>
-        <p:spPr>
-          <a:xfrm>
-            <a:off x="3429000" y="2057400"/>
-            <a:ext cx="2286000" cy="320040"/>
+      <p:sp>
+        <p:nvSpPr>
+          <p:cNvPr id="8" name="Text 6"/>
+          <p:cNvSpPr txBox="1"/>
+          <p:nvPr/>
+        </p:nvSpPr>
+        <p:spPr>
+          <a:xfrm>
+            <a:off x="3246120" y="1463040"/>
+            <a:ext cx="2103120" cy="640080"/>
           </a:xfrm>
           <a:prstGeom prst="rect">
             <a:avLst/>
@@ -9535,30 +9259,30 @@
               <a:buNone/>
             </a:pPr>
             <a:r>
-              <a:rPr lang="en-US" sz="1600" b="1" dirty="0">
-                <a:solidFill>
-                  <a:srgbClr val="0B2545"/>
+              <a:rPr lang="en-US" sz="2800" b="1" dirty="0">
+                <a:solidFill>
+                  <a:srgbClr val="13A89E"/>
                 </a:solidFill>
                 <a:latin typeface="Cambria" pitchFamily="34" charset="0"/>
                 <a:ea typeface="Cambria" pitchFamily="34" charset="-122"/>
                 <a:cs typeface="Cambria" pitchFamily="34" charset="-120"/>
               </a:rPr>
-              <a:t>Web 2.0 and Mobile</a:t>
-            </a:r>
-            <a:endParaRPr lang="en-US" sz="1600" dirty="0"/>
-          </a:p>
-        </p:txBody>
-      </p:sp>
-      <p:sp>
-        <p:nvSpPr>
-          <p:cNvPr id="11" name="Text 7"/>
-          <p:cNvSpPr txBox="1"/>
-          <p:nvPr/>
-        </p:nvSpPr>
-        <p:spPr>
-          <a:xfrm>
-            <a:off x="3429000" y="2395728"/>
-            <a:ext cx="2286000" cy="1325880"/>
+              <a:t>-8 to -10%</a:t>
+            </a:r>
+            <a:endParaRPr lang="en-US" sz="2800" dirty="0"/>
+          </a:p>
+        </p:txBody>
+      </p:sp>
+      <p:sp>
+        <p:nvSpPr>
+          <p:cNvPr id="9" name="Text 7"/>
+          <p:cNvSpPr txBox="1"/>
+          <p:nvPr/>
+        </p:nvSpPr>
+        <p:spPr>
+          <a:xfrm>
+            <a:off x="3246120" y="2103120"/>
+            <a:ext cx="2103120" cy="594360"/>
           </a:xfrm>
           <a:prstGeom prst="rect">
             <a:avLst/>
@@ -9582,7 +9306,7 @@
                 <a:ea typeface="Calibri" pitchFamily="34" charset="-122"/>
                 <a:cs typeface="Calibri" pitchFamily="34" charset="-120"/>
               </a:rPr>
-              <a:t>CRM, customer portal, estimates and work orders, drag-and-drop scheduling, eSignature, payments via ValPay. Offline-first tech app with voice notes and photos.</a:t>
+              <a:t>new powerboat retail sales, 2025</a:t>
             </a:r>
             <a:endParaRPr lang="en-US" sz="1100" dirty="0"/>
           </a:p>
@@ -9590,18 +9314,18 @@
       </p:sp>
       <p:sp>
         <p:nvSpPr>
-          <p:cNvPr id="12" name="Shape 8"/>
+          <p:cNvPr id="10" name="Shape 8"/>
           <p:cNvSpPr/>
           <p:nvPr/>
         </p:nvSpPr>
         <p:spPr>
           <a:xfrm>
-            <a:off x="6035040" y="1325880"/>
-            <a:ext cx="2606040" cy="2468880"/>
+            <a:off x="457200" y="2971800"/>
+            <a:ext cx="2423160" cy="1463040"/>
           </a:xfrm>
           <a:prstGeom prst="roundRect">
             <a:avLst>
-              <a:gd name="adj" fmla="val 2963"/>
+              <a:gd name="adj" fmla="val 5000"/>
             </a:avLst>
           </a:prstGeom>
           <a:solidFill>
@@ -9615,40 +9339,16 @@
           </a:ln>
         </p:spPr>
       </p:sp>
-      <p:pic>
-        <p:nvPicPr>
-          <p:cNvPr id="13" name="Image 2" descr="preencoded.png">    </p:cNvPr>
-          <p:cNvPicPr>
-            <a:picLocks noChangeAspect="1"/>
-          </p:cNvPicPr>
-          <p:nvPr/>
-        </p:nvPicPr>
-        <p:blipFill>
-          <a:blip r:embed="rId3"/>
-          <a:stretch>
-            <a:fillRect/>
-          </a:stretch>
-        </p:blipFill>
-        <p:spPr>
-          <a:xfrm>
-            <a:off x="6217920" y="1508760"/>
-            <a:ext cx="457200" cy="457200"/>
-          </a:xfrm>
-          <a:prstGeom prst="rect">
-            <a:avLst/>
-          </a:prstGeom>
-        </p:spPr>
-      </p:pic>
-      <p:sp>
-        <p:nvSpPr>
-          <p:cNvPr id="14" name="Text 9"/>
-          <p:cNvSpPr txBox="1"/>
-          <p:nvPr/>
-        </p:nvSpPr>
-        <p:spPr>
-          <a:xfrm>
-            <a:off x="6217920" y="2057400"/>
-            <a:ext cx="2286000" cy="320040"/>
+      <p:sp>
+        <p:nvSpPr>
+          <p:cNvPr id="11" name="Text 9"/>
+          <p:cNvSpPr txBox="1"/>
+          <p:nvPr/>
+        </p:nvSpPr>
+        <p:spPr>
+          <a:xfrm>
+            <a:off x="640080" y="3108960"/>
+            <a:ext cx="2103120" cy="640080"/>
           </a:xfrm>
           <a:prstGeom prst="rect">
             <a:avLst/>
@@ -9664,30 +9364,30 @@
               <a:buNone/>
             </a:pPr>
             <a:r>
-              <a:rPr lang="en-US" sz="1600" b="1" dirty="0">
-                <a:solidFill>
-                  <a:srgbClr val="0B2545"/>
+              <a:rPr lang="en-US" sz="2800" b="1" dirty="0">
+                <a:solidFill>
+                  <a:srgbClr val="13A89E"/>
                 </a:solidFill>
                 <a:latin typeface="Cambria" pitchFamily="34" charset="0"/>
                 <a:ea typeface="Cambria" pitchFamily="34" charset="-122"/>
                 <a:cs typeface="Cambria" pitchFamily="34" charset="-120"/>
               </a:rPr>
-              <a:t>AI shipped</a:t>
-            </a:r>
-            <a:endParaRPr lang="en-US" sz="1600" dirty="0"/>
-          </a:p>
-        </p:txBody>
-      </p:sp>
-      <p:sp>
-        <p:nvSpPr>
-          <p:cNvPr id="15" name="Text 10"/>
-          <p:cNvSpPr txBox="1"/>
-          <p:nvPr/>
-        </p:nvSpPr>
-        <p:spPr>
-          <a:xfrm>
-            <a:off x="6217920" y="2395728"/>
-            <a:ext cx="2286000" cy="1325880"/>
+              <a:t>~860k</a:t>
+            </a:r>
+            <a:endParaRPr lang="en-US" sz="2800" dirty="0"/>
+          </a:p>
+        </p:txBody>
+      </p:sp>
+      <p:sp>
+        <p:nvSpPr>
+          <p:cNvPr id="12" name="Text 10"/>
+          <p:cNvSpPr txBox="1"/>
+          <p:nvPr/>
+        </p:nvSpPr>
+        <p:spPr>
+          <a:xfrm>
+            <a:off x="640080" y="3749040"/>
+            <a:ext cx="2103120" cy="594360"/>
           </a:xfrm>
           <a:prstGeom prst="rect">
             <a:avLst/>
@@ -9711,7 +9411,7 @@
                 <a:ea typeface="Calibri" pitchFamily="34" charset="-122"/>
                 <a:cs typeface="Calibri" pitchFamily="34" charset="-120"/>
               </a:rPr>
-              <a:t>AI Scheduling Assistant recommends technician slots; staff accept or reject. Blu Voice Agent (BluSynq) answers calls, quotes and books 24/7.</a:t>
+              <a:t>pre-owned boat sales a year: an ageing fleet needing work</a:t>
             </a:r>
             <a:endParaRPr lang="en-US" sz="1100" dirty="0"/>
           </a:p>
@@ -9719,18 +9419,123 @@
       </p:sp>
       <p:sp>
         <p:nvSpPr>
-          <p:cNvPr id="16" name="Shape 11"/>
+          <p:cNvPr id="13" name="Shape 11"/>
           <p:cNvSpPr/>
           <p:nvPr/>
         </p:nvSpPr>
         <p:spPr>
           <a:xfrm>
-            <a:off x="457200" y="3977640"/>
-            <a:ext cx="8229600" cy="640080"/>
+            <a:off x="3063240" y="2971800"/>
+            <a:ext cx="2423160" cy="1463040"/>
           </a:xfrm>
           <a:prstGeom prst="roundRect">
             <a:avLst>
-              <a:gd name="adj" fmla="val 11429"/>
+              <a:gd name="adj" fmla="val 5000"/>
+            </a:avLst>
+          </a:prstGeom>
+          <a:solidFill>
+            <a:srgbClr val="F3F6F8"/>
+          </a:solidFill>
+          <a:ln w="6350">
+            <a:solidFill>
+              <a:srgbClr val="F3F6F8"/>
+            </a:solidFill>
+            <a:prstDash val="solid"/>
+          </a:ln>
+        </p:spPr>
+      </p:sp>
+      <p:sp>
+        <p:nvSpPr>
+          <p:cNvPr id="14" name="Text 12"/>
+          <p:cNvSpPr txBox="1"/>
+          <p:nvPr/>
+        </p:nvSpPr>
+        <p:spPr>
+          <a:xfrm>
+            <a:off x="3246120" y="3108960"/>
+            <a:ext cx="2103120" cy="640080"/>
+          </a:xfrm>
+          <a:prstGeom prst="rect">
+            <a:avLst/>
+          </a:prstGeom>
+          <a:noFill/>
+          <a:ln/>
+        </p:spPr>
+        <p:txBody>
+          <a:bodyPr wrap="square" lIns="0" tIns="0" rIns="0" bIns="0" rtlCol="0" anchor="ctr"/>
+          <a:lstStyle/>
+          <a:p>
+            <a:pPr indent="0" marL="0">
+              <a:buNone/>
+            </a:pPr>
+            <a:r>
+              <a:rPr lang="en-US" sz="2800" b="1" dirty="0">
+                <a:solidFill>
+                  <a:srgbClr val="13A89E"/>
+                </a:solidFill>
+                <a:latin typeface="Cambria" pitchFamily="34" charset="0"/>
+                <a:ea typeface="Cambria" pitchFamily="34" charset="-122"/>
+                <a:cs typeface="Cambria" pitchFamily="34" charset="-120"/>
+              </a:rPr>
+              <a:t>73% / 67%</a:t>
+            </a:r>
+            <a:endParaRPr lang="en-US" sz="2800" dirty="0"/>
+          </a:p>
+        </p:txBody>
+      </p:sp>
+      <p:sp>
+        <p:nvSpPr>
+          <p:cNvPr id="15" name="Text 13"/>
+          <p:cNvSpPr txBox="1"/>
+          <p:nvPr/>
+        </p:nvSpPr>
+        <p:spPr>
+          <a:xfrm>
+            <a:off x="3246120" y="3749040"/>
+            <a:ext cx="2103120" cy="594360"/>
+          </a:xfrm>
+          <a:prstGeom prst="rect">
+            <a:avLst/>
+          </a:prstGeom>
+          <a:noFill/>
+          <a:ln/>
+        </p:spPr>
+        <p:txBody>
+          <a:bodyPr wrap="square" lIns="0" tIns="0" rIns="0" bIns="0" rtlCol="0" anchor="t"/>
+          <a:lstStyle/>
+          <a:p>
+            <a:pPr indent="0" marL="0">
+              <a:buNone/>
+            </a:pPr>
+            <a:r>
+              <a:rPr lang="en-US" sz="1100" dirty="0">
+                <a:solidFill>
+                  <a:srgbClr val="1B2430"/>
+                </a:solidFill>
+                <a:latin typeface="Calibri" pitchFamily="34" charset="0"/>
+                <a:ea typeface="Calibri" pitchFamily="34" charset="-122"/>
+                <a:cs typeface="Calibri" pitchFamily="34" charset="-120"/>
+              </a:rPr>
+              <a:t>of marinas report insurance and staffing costs up</a:t>
+            </a:r>
+            <a:endParaRPr lang="en-US" sz="1100" dirty="0"/>
+          </a:p>
+        </p:txBody>
+      </p:sp>
+      <p:sp>
+        <p:nvSpPr>
+          <p:cNvPr id="16" name="Shape 14"/>
+          <p:cNvSpPr/>
+          <p:nvPr/>
+        </p:nvSpPr>
+        <p:spPr>
+          <a:xfrm>
+            <a:off x="5852160" y="1325880"/>
+            <a:ext cx="2834640" cy="3291840"/>
+          </a:xfrm>
+          <a:prstGeom prst="roundRect">
+            <a:avLst>
+              <a:gd name="adj" fmla="val 2581"/>
             </a:avLst>
           </a:prstGeom>
           <a:solidFill>
@@ -9744,16 +9549,40 @@
           </a:ln>
         </p:spPr>
       </p:sp>
-      <p:sp>
-        <p:nvSpPr>
-          <p:cNvPr id="17" name="Text 12"/>
-          <p:cNvSpPr txBox="1"/>
-          <p:nvPr/>
-        </p:nvSpPr>
-        <p:spPr>
-          <a:xfrm>
-            <a:off x="640080" y="4023360"/>
-            <a:ext cx="7863840" cy="548640"/>
+      <p:pic>
+        <p:nvPicPr>
+          <p:cNvPr id="17" name="Image 0" descr="preencoded.png">    </p:cNvPr>
+          <p:cNvPicPr>
+            <a:picLocks noChangeAspect="1"/>
+          </p:cNvPicPr>
+          <p:nvPr/>
+        </p:nvPicPr>
+        <p:blipFill>
+          <a:blip r:embed="rId1"/>
+          <a:stretch>
+            <a:fillRect/>
+          </a:stretch>
+        </p:blipFill>
+        <p:spPr>
+          <a:xfrm>
+            <a:off x="6035040" y="1463040"/>
+            <a:ext cx="411480" cy="411480"/>
+          </a:xfrm>
+          <a:prstGeom prst="rect">
+            <a:avLst/>
+          </a:prstGeom>
+        </p:spPr>
+      </p:pic>
+      <p:sp>
+        <p:nvSpPr>
+          <p:cNvPr id="18" name="Text 15"/>
+          <p:cNvSpPr txBox="1"/>
+          <p:nvPr/>
+        </p:nvSpPr>
+        <p:spPr>
+          <a:xfrm>
+            <a:off x="6537960" y="1481328"/>
+            <a:ext cx="2011680" cy="365760"/>
           </a:xfrm>
           <a:prstGeom prst="rect">
             <a:avLst/>
@@ -9769,21 +9598,71 @@
               <a:buNone/>
             </a:pPr>
             <a:r>
-              <a:rPr lang="en-US" sz="1150" b="1" dirty="0">
+              <a:rPr lang="en-US" sz="1500" b="1" dirty="0">
                 <a:solidFill>
                   <a:srgbClr val="0B2545"/>
+                </a:solidFill>
+                <a:latin typeface="Cambria" pitchFamily="34" charset="0"/>
+                <a:ea typeface="Cambria" pitchFamily="34" charset="-122"/>
+                <a:cs typeface="Cambria" pitchFamily="34" charset="-120"/>
+              </a:rPr>
+              <a:t>What it means</a:t>
+            </a:r>
+            <a:endParaRPr lang="en-US" sz="1500" dirty="0"/>
+          </a:p>
+        </p:txBody>
+      </p:sp>
+      <p:sp>
+        <p:nvSpPr>
+          <p:cNvPr id="19" name="Text 16"/>
+          <p:cNvSpPr txBox="1"/>
+          <p:nvPr/>
+        </p:nvSpPr>
+        <p:spPr>
+          <a:xfrm>
+            <a:off x="6035040" y="1965960"/>
+            <a:ext cx="2514600" cy="2606040"/>
+          </a:xfrm>
+          <a:prstGeom prst="rect">
+            <a:avLst/>
+          </a:prstGeom>
+          <a:noFill/>
+          <a:ln/>
+        </p:spPr>
+        <p:txBody>
+          <a:bodyPr wrap="square" lIns="0" tIns="0" rIns="0" bIns="0" rtlCol="0" anchor="t"/>
+          <a:lstStyle/>
+          <a:p>
+            <a:pPr marL="152400" indent="-152400">
+              <a:spcAft>
+                <a:spcPts val="800"/>
+              </a:spcAft>
+              <a:buSzPct val="100000"/>
+              <a:buChar char="•"/>
+            </a:pPr>
+            <a:r>
+              <a:rPr lang="en-US" sz="1050" dirty="0">
+                <a:solidFill>
+                  <a:srgbClr val="1B2430"/>
                 </a:solidFill>
                 <a:latin typeface="Calibri" pitchFamily="34" charset="0"/>
                 <a:ea typeface="Calibri" pitchFamily="34" charset="-122"/>
                 <a:cs typeface="Calibri" pitchFamily="34" charset="-120"/>
               </a:rPr>
-              <a:t>The moat: </a:t>
-            </a:r>
-            <a:pPr indent="0" marL="0">
-              <a:buNone/>
-            </a:pPr>
-            <a:r>
-              <a:rPr lang="en-US" sz="1150" dirty="0">
+              <a:t>Service and repair, not boat sales, is where marina revenue grows for the next few years.</a:t>
+            </a:r>
+            <a:endParaRPr lang="en-US" sz="1050" dirty="0"/>
+          </a:p>
+          <a:p>
+            <a:pPr marL="152400" indent="-152400">
+              <a:spcAft>
+                <a:spcPts val="800"/>
+              </a:spcAft>
+              <a:buSzPct val="100000"/>
+              <a:buChar char="•"/>
+            </a:pPr>
+            <a:r>
+              <a:rPr lang="en-US" sz="1050" dirty="0">
                 <a:solidFill>
                   <a:srgbClr val="1B2430"/>
                 </a:solidFill>
@@ -9791,15 +9670,96 @@
                 <a:ea typeface="Calibri" pitchFamily="34" charset="-122"/>
                 <a:cs typeface="Calibri" pitchFamily="34" charset="-120"/>
               </a:rPr>
-              <a:t>nobody else holds decades of operation codes, labour standards, parts usage and vessel histories for full-service yards. Any AI product should be built on that data, and it should hand off to the scheduler and to Blu rather than duplicate them.</a:t>
-            </a:r>
-            <a:endParaRPr lang="en-US" sz="1150" dirty="0"/>
-          </a:p>
-        </p:txBody>
-      </p:sp>
-      <p:sp>
-        <p:nvSpPr>
-          <p:cNvPr id="18" name="Text 13"/>
+              <a:t>Operators are squeezed on cost, so they buy labour leverage, not more seats.</a:t>
+            </a:r>
+            <a:endParaRPr lang="en-US" sz="1050" dirty="0"/>
+          </a:p>
+          <a:p>
+            <a:pPr marL="152400" indent="-152400">
+              <a:spcAft>
+                <a:spcPts val="800"/>
+              </a:spcAft>
+              <a:buSzPct val="100000"/>
+              <a:buChar char="•"/>
+            </a:pPr>
+            <a:r>
+              <a:rPr lang="en-US" sz="1050" dirty="0">
+                <a:solidFill>
+                  <a:srgbClr val="1B2430"/>
+                </a:solidFill>
+                <a:latin typeface="Calibri" pitchFamily="34" charset="0"/>
+                <a:ea typeface="Calibri" pitchFamily="34" charset="-122"/>
+                <a:cs typeface="Calibri" pitchFamily="34" charset="-120"/>
+              </a:rPr>
+              <a:t>PE-backed groups are consolidating marinas and want standard process and cross-site visibility.</a:t>
+            </a:r>
+            <a:endParaRPr lang="en-US" sz="1050" dirty="0"/>
+          </a:p>
+          <a:p>
+            <a:pPr marL="152400" indent="-152400">
+              <a:spcAft>
+                <a:spcPts val="800"/>
+              </a:spcAft>
+              <a:buSzPct val="100000"/>
+              <a:buChar char="•"/>
+            </a:pPr>
+            <a:r>
+              <a:rPr lang="en-US" sz="1050" dirty="0">
+                <a:solidFill>
+                  <a:srgbClr val="1B2430"/>
+                </a:solidFill>
+                <a:latin typeface="Calibri" pitchFamily="34" charset="0"/>
+                <a:ea typeface="Calibri" pitchFamily="34" charset="-122"/>
+                <a:cs typeface="Calibri" pitchFamily="34" charset="-120"/>
+              </a:rPr>
+              <a:t>Any AI product should be measured in billable hours recovered and days to cash.</a:t>
+            </a:r>
+            <a:endParaRPr lang="en-US" sz="1050" dirty="0"/>
+          </a:p>
+        </p:txBody>
+      </p:sp>
+      <p:sp>
+        <p:nvSpPr>
+          <p:cNvPr id="20" name="Text 17"/>
+          <p:cNvSpPr txBox="1"/>
+          <p:nvPr/>
+        </p:nvSpPr>
+        <p:spPr>
+          <a:xfrm>
+            <a:off x="457200" y="4617720"/>
+            <a:ext cx="8229600" cy="182880"/>
+          </a:xfrm>
+          <a:prstGeom prst="rect">
+            <a:avLst/>
+          </a:prstGeom>
+          <a:noFill/>
+          <a:ln/>
+        </p:spPr>
+        <p:txBody>
+          <a:bodyPr wrap="square" lIns="0" tIns="0" rIns="0" bIns="0" rtlCol="0" anchor="ctr"/>
+          <a:lstStyle/>
+          <a:p>
+            <a:pPr indent="0" marL="0">
+              <a:buNone/>
+            </a:pPr>
+            <a:r>
+              <a:rPr lang="en-US" sz="800" dirty="0">
+                <a:solidFill>
+                  <a:srgbClr val="9AA6B2"/>
+                </a:solidFill>
+                <a:latin typeface="Calibri" pitchFamily="34" charset="0"/>
+                <a:ea typeface="Calibri" pitchFamily="34" charset="-122"/>
+                <a:cs typeface="Calibri" pitchFamily="34" charset="-120"/>
+              </a:rPr>
+              <a:t>Sources: Marina Dock Age 2025 survey; IBISWorld; Marina World Jul 2026; NMMA via Vertical IQ</a:t>
+            </a:r>
+            <a:endParaRPr lang="en-US" sz="800" dirty="0"/>
+          </a:p>
+        </p:txBody>
+      </p:sp>
+      <p:sp>
+        <p:nvSpPr>
+          <p:cNvPr id="21" name="Text 18"/>
           <p:cNvSpPr txBox="1"/>
           <p:nvPr/>
         </p:nvSpPr>
@@ -9894,7 +9854,7 @@
                 <a:ea typeface="Cambria" pitchFamily="34" charset="-122"/>
                 <a:cs typeface="Cambria" pitchFamily="34" charset="-120"/>
               </a:rPr>
-              <a:t>Where the market is moving</a:t>
+              <a:t>Competitive position</a:t>
             </a:r>
             <a:endParaRPr lang="en-US" sz="2800" dirty="0"/>
           </a:p>
@@ -9933,7 +9893,7 @@
                 <a:ea typeface="Calibri" pitchFamily="34" charset="-122"/>
                 <a:cs typeface="Calibri" pitchFamily="34" charset="-120"/>
               </a:rPr>
-              <a:t>Competitors own booking or look modern. DockMaster owns the yard.</a:t>
+              <a:t>Rivals book slips or look modern. DockMaster runs the yard, and that is where the money is moving.</a:t>
             </a:r>
             <a:endParaRPr lang="en-US" sz="1300" dirty="0"/>
           </a:p>
@@ -11170,58 +11130,34 @@
         <p:spPr>
           <a:xfrm>
             <a:off x="5852160" y="1325880"/>
-            <a:ext cx="2834640" cy="3246120"/>
+            <a:ext cx="2834640" cy="1554480"/>
           </a:xfrm>
           <a:prstGeom prst="roundRect">
             <a:avLst>
-              <a:gd name="adj" fmla="val 2581"/>
+              <a:gd name="adj" fmla="val 4706"/>
             </a:avLst>
           </a:prstGeom>
           <a:solidFill>
-            <a:srgbClr val="F3F6F8"/>
+            <a:srgbClr val="E3F5F3"/>
           </a:solidFill>
           <a:ln w="6350">
             <a:solidFill>
-              <a:srgbClr val="F3F6F8"/>
+              <a:srgbClr val="E3F5F3"/>
             </a:solidFill>
             <a:prstDash val="solid"/>
           </a:ln>
         </p:spPr>
       </p:sp>
-      <p:pic>
-        <p:nvPicPr>
-          <p:cNvPr id="6" name="Image 0" descr="preencoded.png">    </p:cNvPr>
-          <p:cNvPicPr>
-            <a:picLocks noChangeAspect="1"/>
-          </p:cNvPicPr>
-          <p:nvPr/>
-        </p:nvPicPr>
-        <p:blipFill>
-          <a:blip r:embed="rId1"/>
-          <a:stretch>
-            <a:fillRect/>
-          </a:stretch>
-        </p:blipFill>
-        <p:spPr>
-          <a:xfrm>
-            <a:off x="6035040" y="1463040"/>
-            <a:ext cx="411480" cy="411480"/>
-          </a:xfrm>
-          <a:prstGeom prst="rect">
-            <a:avLst/>
-          </a:prstGeom>
-        </p:spPr>
-      </p:pic>
-      <p:sp>
-        <p:nvSpPr>
-          <p:cNvPr id="7" name="Text 3"/>
-          <p:cNvSpPr txBox="1"/>
-          <p:nvPr/>
-        </p:nvSpPr>
-        <p:spPr>
-          <a:xfrm>
-            <a:off x="6537960" y="1481328"/>
-            <a:ext cx="2011680" cy="365760"/>
+      <p:sp>
+        <p:nvSpPr>
+          <p:cNvPr id="6" name="Text 3"/>
+          <p:cNvSpPr txBox="1"/>
+          <p:nvPr/>
+        </p:nvSpPr>
+        <p:spPr>
+          <a:xfrm>
+            <a:off x="6035040" y="1417320"/>
+            <a:ext cx="2468880" cy="274320"/>
           </a:xfrm>
           <a:prstGeom prst="rect">
             <a:avLst/>
@@ -11237,7 +11173,7 @@
               <a:buNone/>
             </a:pPr>
             <a:r>
-              <a:rPr lang="en-US" sz="1500" b="1" dirty="0">
+              <a:rPr lang="en-US" sz="1300" b="1" dirty="0">
                 <a:solidFill>
                   <a:srgbClr val="0B2545"/>
                 </a:solidFill>
@@ -11245,22 +11181,22 @@
                 <a:ea typeface="Cambria" pitchFamily="34" charset="-122"/>
                 <a:cs typeface="Cambria" pitchFamily="34" charset="-120"/>
               </a:rPr>
-              <a:t>Three shifts</a:t>
-            </a:r>
-            <a:endParaRPr lang="en-US" sz="1500" dirty="0"/>
-          </a:p>
-        </p:txBody>
-      </p:sp>
-      <p:sp>
-        <p:nvSpPr>
-          <p:cNvPr id="8" name="Text 4"/>
-          <p:cNvSpPr txBox="1"/>
-          <p:nvPr/>
-        </p:nvSpPr>
-        <p:spPr>
-          <a:xfrm>
-            <a:off x="6035040" y="1965960"/>
-            <a:ext cx="2514600" cy="2560320"/>
+              <a:t>Defensible</a:t>
+            </a:r>
+            <a:endParaRPr lang="en-US" sz="1300" dirty="0"/>
+          </a:p>
+        </p:txBody>
+      </p:sp>
+      <p:sp>
+        <p:nvSpPr>
+          <p:cNvPr id="7" name="Text 4"/>
+          <p:cNvSpPr txBox="1"/>
+          <p:nvPr/>
+        </p:nvSpPr>
+        <p:spPr>
+          <a:xfrm>
+            <a:off x="6035040" y="1737360"/>
+            <a:ext cx="2514600" cy="1097280"/>
           </a:xfrm>
           <a:prstGeom prst="rect">
             <a:avLst/>
@@ -11274,13 +11210,13 @@
           <a:p>
             <a:pPr marL="152400" indent="-152400">
               <a:spcAft>
-                <a:spcPts val="800"/>
+                <a:spcPts val="400"/>
               </a:spcAft>
               <a:buSzPct val="100000"/>
               <a:buChar char="•"/>
             </a:pPr>
             <a:r>
-              <a:rPr lang="en-US" sz="1050" dirty="0">
+              <a:rPr lang="en-US" sz="1000" dirty="0">
                 <a:solidFill>
                   <a:srgbClr val="1B2430"/>
                 </a:solidFill>
@@ -11288,20 +11224,20 @@
                 <a:ea typeface="Calibri" pitchFamily="34" charset="-122"/>
                 <a:cs typeface="Calibri" pitchFamily="34" charset="-120"/>
               </a:rPr>
-              <a:t>Ageing fleet: ~860k pre-owned boat sales a year and fewer new boats push revenue toward repair and service.</a:t>
-            </a:r>
-            <a:endParaRPr lang="en-US" sz="1050" dirty="0"/>
+              <a:t>Service, parts and accounting depth in one record</a:t>
+            </a:r>
+            <a:endParaRPr lang="en-US" sz="1000" dirty="0"/>
           </a:p>
           <a:p>
             <a:pPr marL="152400" indent="-152400">
               <a:spcAft>
-                <a:spcPts val="800"/>
+                <a:spcPts val="400"/>
               </a:spcAft>
               <a:buSzPct val="100000"/>
               <a:buChar char="•"/>
             </a:pPr>
             <a:r>
-              <a:rPr lang="en-US" sz="1050" dirty="0">
+              <a:rPr lang="en-US" sz="1000" dirty="0">
                 <a:solidFill>
                   <a:srgbClr val="1B2430"/>
                 </a:solidFill>
@@ -11309,20 +11245,20 @@
                 <a:ea typeface="Calibri" pitchFamily="34" charset="-122"/>
                 <a:cs typeface="Calibri" pitchFamily="34" charset="-120"/>
               </a:rPr>
-              <a:t>Cost squeeze: insurance, maintenance and staffing all up. Buyers want labour leverage.</a:t>
-            </a:r>
-            <a:endParaRPr lang="en-US" sz="1050" dirty="0"/>
+              <a:t>Decades of structured work orders and vessel history</a:t>
+            </a:r>
+            <a:endParaRPr lang="en-US" sz="1000" dirty="0"/>
           </a:p>
           <a:p>
             <a:pPr marL="152400" indent="-152400">
               <a:spcAft>
-                <a:spcPts val="800"/>
+                <a:spcPts val="400"/>
               </a:spcAft>
               <a:buSzPct val="100000"/>
               <a:buChar char="•"/>
             </a:pPr>
             <a:r>
-              <a:rPr lang="en-US" sz="1050" dirty="0">
+              <a:rPr lang="en-US" sz="1000" dirty="0">
                 <a:solidFill>
                   <a:srgbClr val="1B2430"/>
                 </a:solidFill>
@@ -11330,15 +11266,166 @@
                 <a:ea typeface="Calibri" pitchFamily="34" charset="-122"/>
                 <a:cs typeface="Calibri" pitchFamily="34" charset="-120"/>
               </a:rPr>
-              <a:t>Consolidation: PE-backed groups want standard process and cross-site visibility.</a:t>
-            </a:r>
-            <a:endParaRPr lang="en-US" sz="1050" dirty="0"/>
-          </a:p>
-        </p:txBody>
-      </p:sp>
-      <p:sp>
-        <p:nvSpPr>
-          <p:cNvPr id="9" name="Text 5"/>
+              <a:t>An API and a 1,000+ install base</a:t>
+            </a:r>
+            <a:endParaRPr lang="en-US" sz="1000" dirty="0"/>
+          </a:p>
+        </p:txBody>
+      </p:sp>
+      <p:sp>
+        <p:nvSpPr>
+          <p:cNvPr id="8" name="Shape 5"/>
+          <p:cNvSpPr/>
+          <p:nvPr/>
+        </p:nvSpPr>
+        <p:spPr>
+          <a:xfrm>
+            <a:off x="5852160" y="3017520"/>
+            <a:ext cx="2834640" cy="1600200"/>
+          </a:xfrm>
+          <a:prstGeom prst="roundRect">
+            <a:avLst>
+              <a:gd name="adj" fmla="val 4571"/>
+            </a:avLst>
+          </a:prstGeom>
+          <a:solidFill>
+            <a:srgbClr val="FCF1DF"/>
+          </a:solidFill>
+          <a:ln w="6350">
+            <a:solidFill>
+              <a:srgbClr val="FCF1DF"/>
+            </a:solidFill>
+            <a:prstDash val="solid"/>
+          </a:ln>
+        </p:spPr>
+      </p:sp>
+      <p:sp>
+        <p:nvSpPr>
+          <p:cNvPr id="9" name="Text 6"/>
+          <p:cNvSpPr txBox="1"/>
+          <p:nvPr/>
+        </p:nvSpPr>
+        <p:spPr>
+          <a:xfrm>
+            <a:off x="6035040" y="3108960"/>
+            <a:ext cx="2468880" cy="274320"/>
+          </a:xfrm>
+          <a:prstGeom prst="rect">
+            <a:avLst/>
+          </a:prstGeom>
+          <a:noFill/>
+          <a:ln/>
+        </p:spPr>
+        <p:txBody>
+          <a:bodyPr wrap="square" lIns="0" tIns="0" rIns="0" bIns="0" rtlCol="0" anchor="ctr"/>
+          <a:lstStyle/>
+          <a:p>
+            <a:pPr indent="0" marL="0">
+              <a:buNone/>
+            </a:pPr>
+            <a:r>
+              <a:rPr lang="en-US" sz="1300" b="1" dirty="0">
+                <a:solidFill>
+                  <a:srgbClr val="0B2545"/>
+                </a:solidFill>
+                <a:latin typeface="Cambria" pitchFamily="34" charset="0"/>
+                <a:ea typeface="Cambria" pitchFamily="34" charset="-122"/>
+                <a:cs typeface="Cambria" pitchFamily="34" charset="-120"/>
+              </a:rPr>
+              <a:t>Exposed</a:t>
+            </a:r>
+            <a:endParaRPr lang="en-US" sz="1300" dirty="0"/>
+          </a:p>
+        </p:txBody>
+      </p:sp>
+      <p:sp>
+        <p:nvSpPr>
+          <p:cNvPr id="10" name="Text 7"/>
+          <p:cNvSpPr txBox="1"/>
+          <p:nvPr/>
+        </p:nvSpPr>
+        <p:spPr>
+          <a:xfrm>
+            <a:off x="6035040" y="3429000"/>
+            <a:ext cx="2514600" cy="1143000"/>
+          </a:xfrm>
+          <a:prstGeom prst="rect">
+            <a:avLst/>
+          </a:prstGeom>
+          <a:noFill/>
+          <a:ln/>
+        </p:spPr>
+        <p:txBody>
+          <a:bodyPr wrap="square" lIns="0" tIns="0" rIns="0" bIns="0" rtlCol="0" anchor="t"/>
+          <a:lstStyle/>
+          <a:p>
+            <a:pPr marL="152400" indent="-152400">
+              <a:spcAft>
+                <a:spcPts val="400"/>
+              </a:spcAft>
+              <a:buSzPct val="100000"/>
+              <a:buChar char="•"/>
+            </a:pPr>
+            <a:r>
+              <a:rPr lang="en-US" sz="1000" dirty="0">
+                <a:solidFill>
+                  <a:srgbClr val="1B2430"/>
+                </a:solidFill>
+                <a:latin typeface="Calibri" pitchFamily="34" charset="0"/>
+                <a:ea typeface="Calibri" pitchFamily="34" charset="-122"/>
+                <a:cs typeface="Calibri" pitchFamily="34" charset="-120"/>
+              </a:rPr>
+              <a:t>Capterra 3.9: "clunky", GUI needs a refresh</a:t>
+            </a:r>
+            <a:endParaRPr lang="en-US" sz="1000" dirty="0"/>
+          </a:p>
+          <a:p>
+            <a:pPr marL="152400" indent="-152400">
+              <a:spcAft>
+                <a:spcPts val="400"/>
+              </a:spcAft>
+              <a:buSzPct val="100000"/>
+              <a:buChar char="•"/>
+            </a:pPr>
+            <a:r>
+              <a:rPr lang="en-US" sz="1000" dirty="0">
+                <a:solidFill>
+                  <a:srgbClr val="1B2430"/>
+                </a:solidFill>
+                <a:latin typeface="Calibri" pitchFamily="34" charset="0"/>
+                <a:ea typeface="Calibri" pitchFamily="34" charset="-122"/>
+                <a:cs typeface="Calibri" pitchFamily="34" charset="-120"/>
+              </a:rPr>
+              <a:t>Desktop-only accounts are slow to move to Web</a:t>
+            </a:r>
+            <a:endParaRPr lang="en-US" sz="1000" dirty="0"/>
+          </a:p>
+          <a:p>
+            <a:pPr marL="152400" indent="-152400">
+              <a:spcAft>
+                <a:spcPts val="400"/>
+              </a:spcAft>
+              <a:buSzPct val="100000"/>
+              <a:buChar char="•"/>
+            </a:pPr>
+            <a:r>
+              <a:rPr lang="en-US" sz="1000" dirty="0">
+                <a:solidFill>
+                  <a:srgbClr val="1B2430"/>
+                </a:solidFill>
+                <a:latin typeface="Calibri" pitchFamily="34" charset="0"/>
+                <a:ea typeface="Calibri" pitchFamily="34" charset="-122"/>
+                <a:cs typeface="Calibri" pitchFamily="34" charset="-120"/>
+              </a:rPr>
+              <a:t>AI-native entrants will pitch the small-shop base first</a:t>
+            </a:r>
+            <a:endParaRPr lang="en-US" sz="1000" dirty="0"/>
+          </a:p>
+        </p:txBody>
+      </p:sp>
+      <p:sp>
+        <p:nvSpPr>
+          <p:cNvPr id="11" name="Text 8"/>
           <p:cNvSpPr txBox="1"/>
           <p:nvPr/>
         </p:nvSpPr>
@@ -11433,7 +11520,7 @@
                 <a:ea typeface="Cambria" pitchFamily="34" charset="-122"/>
                 <a:cs typeface="Cambria" pitchFamily="34" charset="-120"/>
               </a:rPr>
-              <a:t>Ideal customer profile</a:t>
+              <a:t>The customer with the most to gain</a:t>
             </a:r>
             <a:endParaRPr lang="en-US" sz="2800" dirty="0"/>
           </a:p>
@@ -11472,7 +11559,7 @@
                 <a:ea typeface="Calibri" pitchFamily="34" charset="-122"/>
                 <a:cs typeface="Calibri" pitchFamily="34" charset="-120"/>
               </a:rPr>
-              <a:t>The full-service marina or boatyard with a real service department</a:t>
+              <a:t>Within DockMaster's base, the full-service yard with a real service department is where the pain and the money sit</a:t>
             </a:r>
             <a:endParaRPr lang="en-US" sz="1300" dirty="0"/>
           </a:p>
@@ -11562,7 +11649,7 @@
                 <a:ea typeface="Cambria" pitchFamily="34" charset="-122"/>
                 <a:cs typeface="Cambria" pitchFamily="34" charset="-120"/>
               </a:rPr>
-              <a:t>Primary ICP</a:t>
+              <a:t>The segment</a:t>
             </a:r>
             <a:endParaRPr lang="en-US" sz="1500" dirty="0"/>
           </a:p>
@@ -11591,13 +11678,13 @@
           <a:p>
             <a:pPr marL="152400" indent="-152400">
               <a:spcAft>
-                <a:spcPts val="700"/>
+                <a:spcPts val="600"/>
               </a:spcAft>
               <a:buSzPct val="100000"/>
               <a:buChar char="•"/>
             </a:pPr>
             <a:r>
-              <a:rPr lang="en-US" sz="1050" dirty="0">
+              <a:rPr lang="en-US" sz="1000" dirty="0">
                 <a:solidFill>
                   <a:srgbClr val="1B2430"/>
                 </a:solidFill>
@@ -11607,18 +11694,18 @@
               </a:rPr>
               <a:t>50-500 slips or dry stack plus a repair shop with 3-25 technicians and a parts room</a:t>
             </a:r>
-            <a:endParaRPr lang="en-US" sz="1050" dirty="0"/>
+            <a:endParaRPr lang="en-US" sz="1000" dirty="0"/>
           </a:p>
           <a:p>
             <a:pPr marL="152400" indent="-152400">
               <a:spcAft>
-                <a:spcPts val="700"/>
+                <a:spcPts val="600"/>
               </a:spcAft>
               <a:buSzPct val="100000"/>
               <a:buChar char="•"/>
             </a:pPr>
             <a:r>
-              <a:rPr lang="en-US" sz="1050" dirty="0">
+              <a:rPr lang="en-US" sz="1000" dirty="0">
                 <a:solidFill>
                   <a:srgbClr val="1B2430"/>
                 </a:solidFill>
@@ -11628,18 +11715,18 @@
               </a:rPr>
               <a:t>$2M-$30M revenue, 10-60 staff, sharply seasonal (spring commissioning, fall haul-out)</a:t>
             </a:r>
-            <a:endParaRPr lang="en-US" sz="1050" dirty="0"/>
+            <a:endParaRPr lang="en-US" sz="1000" dirty="0"/>
           </a:p>
           <a:p>
             <a:pPr marL="152400" indent="-152400">
               <a:spcAft>
-                <a:spcPts val="700"/>
+                <a:spcPts val="600"/>
               </a:spcAft>
               <a:buSzPct val="100000"/>
               <a:buChar char="•"/>
             </a:pPr>
             <a:r>
-              <a:rPr lang="en-US" sz="1050" dirty="0">
+              <a:rPr lang="en-US" sz="1000" dirty="0">
                 <a:solidFill>
                   <a:srgbClr val="1B2430"/>
                 </a:solidFill>
@@ -11647,20 +11734,20 @@
                 <a:ea typeface="Calibri" pitchFamily="34" charset="-122"/>
                 <a:cs typeface="Calibri" pitchFamily="34" charset="-120"/>
               </a:rPr>
-              <a:t>Already on Desktop; partially on Web 2.0 and Mobile; runs accounting in DockMaster</a:t>
-            </a:r>
-            <a:endParaRPr lang="en-US" sz="1050" dirty="0"/>
+              <a:t>Most are on Desktop, partly on Web 2.0 and Mobile, and run accounting in DockMaster. Examples: Shearwater Marine, RMK Merrill-Stevens, West Alton Marina</a:t>
+            </a:r>
+            <a:endParaRPr lang="en-US" sz="1000" dirty="0"/>
           </a:p>
           <a:p>
             <a:pPr marL="152400" indent="-152400">
               <a:spcAft>
-                <a:spcPts val="700"/>
+                <a:spcPts val="600"/>
               </a:spcAft>
               <a:buSzPct val="100000"/>
               <a:buChar char="•"/>
             </a:pPr>
             <a:r>
-              <a:rPr lang="en-US" sz="1050" dirty="0">
+              <a:rPr lang="en-US" sz="1000" dirty="0">
                 <a:solidFill>
                   <a:srgbClr val="1B2430"/>
                 </a:solidFill>
@@ -11668,20 +11755,20 @@
                 <a:ea typeface="Calibri" pitchFamily="34" charset="-122"/>
                 <a:cs typeface="Calibri" pitchFamily="34" charset="-120"/>
               </a:rPr>
-              <a:t>Examples from their own case studies: Shearwater Marine, RMK Merrill-Stevens, West Alton Marina</a:t>
-            </a:r>
-            <a:endParaRPr lang="en-US" sz="1050" dirty="0"/>
+              <a:t>The same yards exist outside the base, on Molo, MarinaOffice or spreadsheets</a:t>
+            </a:r>
+            <a:endParaRPr lang="en-US" sz="1000" dirty="0"/>
           </a:p>
           <a:p>
             <a:pPr marL="152400" indent="-152400">
               <a:spcAft>
-                <a:spcPts val="700"/>
+                <a:spcPts val="600"/>
               </a:spcAft>
               <a:buSzPct val="100000"/>
               <a:buChar char="•"/>
             </a:pPr>
             <a:r>
-              <a:rPr lang="en-US" sz="1050" dirty="0">
+              <a:rPr lang="en-US" sz="1000" dirty="0">
                 <a:solidFill>
                   <a:srgbClr val="1B2430"/>
                 </a:solidFill>
@@ -11689,9 +11776,9 @@
                 <a:ea typeface="Calibri" pitchFamily="34" charset="-122"/>
                 <a:cs typeface="Calibri" pitchFamily="34" charset="-120"/>
               </a:rPr>
-              <a:t>Secondary: multi-site PE groups (high ACV) and small service shops from the Dockworks base (standalone candidate). Yacht clubs and rental businesses are phase two: less service data.</a:t>
-            </a:r>
-            <a:endParaRPr lang="en-US" sz="1050" dirty="0"/>
+              <a:t>PE-backed multi-site groups add scale. Yacht clubs and rental businesses carry far less service data, so less to gain.</a:t>
+            </a:r>
+            <a:endParaRPr lang="en-US" sz="1000" dirty="0"/>
           </a:p>
         </p:txBody>
       </p:sp>
@@ -12308,7 +12395,7 @@
                 <a:ea typeface="Cambria" pitchFamily="34" charset="-122"/>
                 <a:cs typeface="Cambria" pitchFamily="34" charset="-120"/>
               </a:rPr>
-              <a:t>Opportunity map</a:t>
+              <a:t>Three products, one thread: service revenue</a:t>
             </a:r>
             <a:endParaRPr lang="en-US" sz="2800" dirty="0"/>
           </a:p>
@@ -12347,42 +12434,26 @@
                 <a:ea typeface="Calibri" pitchFamily="34" charset="-122"/>
                 <a:cs typeface="Calibri" pitchFamily="34" charset="-120"/>
               </a:rPr>
-              <a:t>Eight candidates scored 1-5 on customer revenue, DockMaster revenue, data moat, 12-month feasibility and fit with existing AI</a:t>
+              <a:t>Built for that yard. Write it faster, find more of it, collect it sooner, all from data DockMaster already holds.</a:t>
             </a:r>
             <a:endParaRPr lang="en-US" sz="1300" dirty="0"/>
           </a:p>
         </p:txBody>
       </p:sp>
-      <p:graphicFrame>
-        <p:nvGraphicFramePr>
-          <p:cNvPr id="4" name="Chart 0" descr=""/>
-          <p:cNvGraphicFramePr/>
-          <p:nvPr/>
-        </p:nvGraphicFramePr>
-        <p:xfrm>
-          <a:off x="457200" y="1280160"/>
-          <a:ext cx="5120640" cy="3383280"/>
-        </p:xfrm>
-        <a:graphic xmlns:a="http://schemas.openxmlformats.org/drawingml/2006/main">
-          <a:graphicData uri="http://schemas.openxmlformats.org/drawingml/2006/chart">
-            <c:chart xmlns:c="http://schemas.openxmlformats.org/drawingml/2006/chart" r:id="rId1"/>
-          </a:graphicData>
-        </a:graphic>
-      </p:graphicFrame>
-      <p:sp>
-        <p:nvSpPr>
-          <p:cNvPr id="5" name="Shape 2"/>
+      <p:sp>
+        <p:nvSpPr>
+          <p:cNvPr id="4" name="Shape 2"/>
           <p:cNvSpPr/>
           <p:nvPr/>
         </p:nvSpPr>
         <p:spPr>
           <a:xfrm>
-            <a:off x="5852160" y="1325880"/>
-            <a:ext cx="2834640" cy="3246120"/>
+            <a:off x="457200" y="1325880"/>
+            <a:ext cx="2606040" cy="2697480"/>
           </a:xfrm>
           <a:prstGeom prst="roundRect">
             <a:avLst>
-              <a:gd name="adj" fmla="val 2581"/>
+              <a:gd name="adj" fmla="val 2807"/>
             </a:avLst>
           </a:prstGeom>
           <a:solidFill>
@@ -12396,6 +12467,30 @@
           </a:ln>
         </p:spPr>
       </p:sp>
+      <p:pic>
+        <p:nvPicPr>
+          <p:cNvPr id="5" name="Image 0" descr="preencoded.png">    </p:cNvPr>
+          <p:cNvPicPr>
+            <a:picLocks noChangeAspect="1"/>
+          </p:cNvPicPr>
+          <p:nvPr/>
+        </p:nvPicPr>
+        <p:blipFill>
+          <a:blip r:embed="rId1"/>
+          <a:stretch>
+            <a:fillRect/>
+          </a:stretch>
+        </p:blipFill>
+        <p:spPr>
+          <a:xfrm>
+            <a:off x="640080" y="1463040"/>
+            <a:ext cx="411480" cy="411480"/>
+          </a:xfrm>
+          <a:prstGeom prst="rect">
+            <a:avLst/>
+          </a:prstGeom>
+        </p:spPr>
+      </p:pic>
       <p:sp>
         <p:nvSpPr>
           <p:cNvPr id="6" name="Text 3"/>
@@ -12404,8 +12499,8 @@
         </p:nvSpPr>
         <p:spPr>
           <a:xfrm>
-            <a:off x="6035040" y="1417320"/>
-            <a:ext cx="2468880" cy="320040"/>
+            <a:off x="1143000" y="1481328"/>
+            <a:ext cx="1874520" cy="365760"/>
           </a:xfrm>
           <a:prstGeom prst="rect">
             <a:avLst/>
@@ -12421,7 +12516,7 @@
               <a:buNone/>
             </a:pPr>
             <a:r>
-              <a:rPr lang="en-US" sz="1500" b="1" dirty="0">
+              <a:rPr lang="en-US" sz="1350" b="1" dirty="0">
                 <a:solidFill>
                   <a:srgbClr val="0B2545"/>
                 </a:solidFill>
@@ -12429,9 +12524,9 @@
                 <a:ea typeface="Cambria" pitchFamily="34" charset="-122"/>
                 <a:cs typeface="Cambria" pitchFamily="34" charset="-120"/>
               </a:rPr>
-              <a:t>The pick</a:t>
-            </a:r>
-            <a:endParaRPr lang="en-US" sz="1500" dirty="0"/>
+              <a:t>1. Service Writer</a:t>
+            </a:r>
+            <a:endParaRPr lang="en-US" sz="1350" dirty="0"/>
           </a:p>
         </p:txBody>
       </p:sp>
@@ -12443,8 +12538,47 @@
         </p:nvSpPr>
         <p:spPr>
           <a:xfrm>
-            <a:off x="6035040" y="1783080"/>
-            <a:ext cx="2514600" cy="2743200"/>
+            <a:off x="640080" y="1965960"/>
+            <a:ext cx="2286000" cy="960120"/>
+          </a:xfrm>
+          <a:prstGeom prst="rect">
+            <a:avLst/>
+          </a:prstGeom>
+          <a:noFill/>
+          <a:ln/>
+        </p:spPr>
+        <p:txBody>
+          <a:bodyPr wrap="square" lIns="0" tIns="0" rIns="0" bIns="0" rtlCol="0" anchor="t"/>
+          <a:lstStyle/>
+          <a:p>
+            <a:pPr indent="0" marL="0">
+              <a:buNone/>
+            </a:pPr>
+            <a:r>
+              <a:rPr lang="en-US" sz="1000" dirty="0">
+                <a:solidFill>
+                  <a:srgbClr val="1B2430"/>
+                </a:solidFill>
+                <a:latin typeface="Calibri" pitchFamily="34" charset="0"/>
+                <a:ea typeface="Calibri" pitchFamily="34" charset="-122"/>
+                <a:cs typeface="Calibri" pitchFamily="34" charset="-120"/>
+              </a:rPr>
+              <a:t>Turns a technician's voice note and photos into a draft estimate from the yard's own operation codes, labour standards and parts, then hands off to eSign and the scheduler.</a:t>
+            </a:r>
+            <a:endParaRPr lang="en-US" sz="1000" dirty="0"/>
+          </a:p>
+        </p:txBody>
+      </p:sp>
+      <p:sp>
+        <p:nvSpPr>
+          <p:cNvPr id="8" name="Text 5"/>
+          <p:cNvSpPr txBox="1"/>
+          <p:nvPr/>
+        </p:nvSpPr>
+        <p:spPr>
+          <a:xfrm>
+            <a:off x="640080" y="2971800"/>
+            <a:ext cx="2286000" cy="1005840"/>
           </a:xfrm>
           <a:prstGeom prst="rect">
             <a:avLst/>
@@ -12458,13 +12592,13 @@
           <a:p>
             <a:pPr marL="152400" indent="-152400">
               <a:spcAft>
-                <a:spcPts val="700"/>
+                <a:spcPts val="400"/>
               </a:spcAft>
               <a:buSzPct val="100000"/>
               <a:buChar char="•"/>
             </a:pPr>
             <a:r>
-              <a:rPr lang="en-US" sz="1050" dirty="0">
+              <a:rPr lang="en-US" sz="950" dirty="0">
                 <a:solidFill>
                   <a:srgbClr val="1B2430"/>
                 </a:solidFill>
@@ -12472,20 +12606,20 @@
                 <a:ea typeface="Calibri" pitchFamily="34" charset="-122"/>
                 <a:cs typeface="Calibri" pitchFamily="34" charset="-120"/>
               </a:rPr>
-              <a:t>Build A, the Service Writer, first.</a:t>
-            </a:r>
-            <a:endParaRPr lang="en-US" sz="1050" dirty="0"/>
+              <a:t>Why it works: every input exists today, nothing new to capture</a:t>
+            </a:r>
+            <a:endParaRPr lang="en-US" sz="950" dirty="0"/>
           </a:p>
           <a:p>
             <a:pPr marL="152400" indent="-152400">
               <a:spcAft>
-                <a:spcPts val="700"/>
+                <a:spcPts val="400"/>
               </a:spcAft>
               <a:buSzPct val="100000"/>
               <a:buChar char="•"/>
             </a:pPr>
             <a:r>
-              <a:rPr lang="en-US" sz="1050" dirty="0">
+              <a:rPr lang="en-US" sz="950" dirty="0">
                 <a:solidFill>
                   <a:srgbClr val="1B2430"/>
                 </a:solidFill>
@@ -12493,20 +12627,171 @@
                 <a:ea typeface="Calibri" pitchFamily="34" charset="-122"/>
                 <a:cs typeface="Calibri" pitchFamily="34" charset="-120"/>
               </a:rPr>
-              <a:t>B (proactive demand) is release two and reuses the same drafting engine.</a:t>
-            </a:r>
-            <a:endParaRPr lang="en-US" sz="1050" dirty="0"/>
-          </a:p>
+              <a:t>ROI in units the GM tracks: turnaround, approval rate, billed vs standard hours</a:t>
+            </a:r>
+            <a:endParaRPr lang="en-US" sz="950" dirty="0"/>
+          </a:p>
+        </p:txBody>
+      </p:sp>
+      <p:sp>
+        <p:nvSpPr>
+          <p:cNvPr id="9" name="Shape 6"/>
+          <p:cNvSpPr/>
+          <p:nvPr/>
+        </p:nvSpPr>
+        <p:spPr>
+          <a:xfrm>
+            <a:off x="3246120" y="1325880"/>
+            <a:ext cx="2606040" cy="2697480"/>
+          </a:xfrm>
+          <a:prstGeom prst="roundRect">
+            <a:avLst>
+              <a:gd name="adj" fmla="val 2807"/>
+            </a:avLst>
+          </a:prstGeom>
+          <a:solidFill>
+            <a:srgbClr val="F3F6F8"/>
+          </a:solidFill>
+          <a:ln w="6350">
+            <a:solidFill>
+              <a:srgbClr val="F3F6F8"/>
+            </a:solidFill>
+            <a:prstDash val="solid"/>
+          </a:ln>
+        </p:spPr>
+      </p:sp>
+      <p:pic>
+        <p:nvPicPr>
+          <p:cNvPr id="10" name="Image 1" descr="preencoded.png">    </p:cNvPr>
+          <p:cNvPicPr>
+            <a:picLocks noChangeAspect="1"/>
+          </p:cNvPicPr>
+          <p:nvPr/>
+        </p:nvPicPr>
+        <p:blipFill>
+          <a:blip r:embed="rId2"/>
+          <a:stretch>
+            <a:fillRect/>
+          </a:stretch>
+        </p:blipFill>
+        <p:spPr>
+          <a:xfrm>
+            <a:off x="3429000" y="1463040"/>
+            <a:ext cx="411480" cy="411480"/>
+          </a:xfrm>
+          <a:prstGeom prst="rect">
+            <a:avLst/>
+          </a:prstGeom>
+        </p:spPr>
+      </p:pic>
+      <p:sp>
+        <p:nvSpPr>
+          <p:cNvPr id="11" name="Text 7"/>
+          <p:cNvSpPr txBox="1"/>
+          <p:nvPr/>
+        </p:nvSpPr>
+        <p:spPr>
+          <a:xfrm>
+            <a:off x="3931920" y="1481328"/>
+            <a:ext cx="1874520" cy="365760"/>
+          </a:xfrm>
+          <a:prstGeom prst="rect">
+            <a:avLst/>
+          </a:prstGeom>
+          <a:noFill/>
+          <a:ln/>
+        </p:spPr>
+        <p:txBody>
+          <a:bodyPr wrap="square" lIns="0" tIns="0" rIns="0" bIns="0" rtlCol="0" anchor="ctr"/>
+          <a:lstStyle/>
+          <a:p>
+            <a:pPr indent="0" marL="0">
+              <a:buNone/>
+            </a:pPr>
+            <a:r>
+              <a:rPr lang="en-US" sz="1350" b="1" dirty="0">
+                <a:solidFill>
+                  <a:srgbClr val="0B2545"/>
+                </a:solidFill>
+                <a:latin typeface="Cambria" pitchFamily="34" charset="0"/>
+                <a:ea typeface="Cambria" pitchFamily="34" charset="-122"/>
+                <a:cs typeface="Cambria" pitchFamily="34" charset="-120"/>
+              </a:rPr>
+              <a:t>2. Proactive service demand</a:t>
+            </a:r>
+            <a:endParaRPr lang="en-US" sz="1350" dirty="0"/>
+          </a:p>
+        </p:txBody>
+      </p:sp>
+      <p:sp>
+        <p:nvSpPr>
+          <p:cNvPr id="12" name="Text 8"/>
+          <p:cNvSpPr txBox="1"/>
+          <p:nvPr/>
+        </p:nvSpPr>
+        <p:spPr>
+          <a:xfrm>
+            <a:off x="3429000" y="1965960"/>
+            <a:ext cx="2286000" cy="960120"/>
+          </a:xfrm>
+          <a:prstGeom prst="rect">
+            <a:avLst/>
+          </a:prstGeom>
+          <a:noFill/>
+          <a:ln/>
+        </p:spPr>
+        <p:txBody>
+          <a:bodyPr wrap="square" lIns="0" tIns="0" rIns="0" bIns="0" rtlCol="0" anchor="t"/>
+          <a:lstStyle/>
+          <a:p>
+            <a:pPr indent="0" marL="0">
+              <a:buNone/>
+            </a:pPr>
+            <a:r>
+              <a:rPr lang="en-US" sz="1000" dirty="0">
+                <a:solidFill>
+                  <a:srgbClr val="1B2430"/>
+                </a:solidFill>
+                <a:latin typeface="Calibri" pitchFamily="34" charset="0"/>
+                <a:ea typeface="Calibri" pitchFamily="34" charset="-122"/>
+                <a:cs typeface="Calibri" pitchFamily="34" charset="-120"/>
+              </a:rPr>
+              <a:t>Predicts per-vessel maintenance from history and intervals, drafts the estimate and a short outreach message before the season starts.</a:t>
+            </a:r>
+            <a:endParaRPr lang="en-US" sz="1000" dirty="0"/>
+          </a:p>
+        </p:txBody>
+      </p:sp>
+      <p:sp>
+        <p:nvSpPr>
+          <p:cNvPr id="13" name="Text 9"/>
+          <p:cNvSpPr txBox="1"/>
+          <p:nvPr/>
+        </p:nvSpPr>
+        <p:spPr>
+          <a:xfrm>
+            <a:off x="3429000" y="2971800"/>
+            <a:ext cx="2286000" cy="1005840"/>
+          </a:xfrm>
+          <a:prstGeom prst="rect">
+            <a:avLst/>
+          </a:prstGeom>
+          <a:noFill/>
+          <a:ln/>
+        </p:spPr>
+        <p:txBody>
+          <a:bodyPr wrap="square" lIns="0" tIns="0" rIns="0" bIns="0" rtlCol="0" anchor="t"/>
+          <a:lstStyle/>
           <a:p>
             <a:pPr marL="152400" indent="-152400">
               <a:spcAft>
-                <a:spcPts val="700"/>
+                <a:spcPts val="400"/>
               </a:spcAft>
               <a:buSzPct val="100000"/>
               <a:buChar char="•"/>
             </a:pPr>
             <a:r>
-              <a:rPr lang="en-US" sz="1050" dirty="0">
+              <a:rPr lang="en-US" sz="950" dirty="0">
                 <a:solidFill>
                   <a:srgbClr val="1B2430"/>
                 </a:solidFill>
@@ -12514,20 +12799,20 @@
                 <a:ea typeface="Calibri" pitchFamily="34" charset="-122"/>
                 <a:cs typeface="Calibri" pitchFamily="34" charset="-120"/>
               </a:rPr>
-              <a:t>C (collections) is the payments-linked upsell that drives ValPay attach.</a:t>
-            </a:r>
-            <a:endParaRPr lang="en-US" sz="1050" dirty="0"/>
+              <a:t>Why it works: finds revenue the yard is already entitled to</a:t>
+            </a:r>
+            <a:endParaRPr lang="en-US" sz="950" dirty="0"/>
           </a:p>
           <a:p>
             <a:pPr marL="152400" indent="-152400">
               <a:spcAft>
-                <a:spcPts val="700"/>
+                <a:spcPts val="400"/>
               </a:spcAft>
               <a:buSzPct val="100000"/>
               <a:buChar char="•"/>
             </a:pPr>
             <a:r>
-              <a:rPr lang="en-US" sz="1050" dirty="0">
+              <a:rPr lang="en-US" sz="950" dirty="0">
                 <a:solidFill>
                   <a:srgbClr val="1B2430"/>
                 </a:solidFill>
@@ -12535,20 +12820,171 @@
                 <a:ea typeface="Calibri" pitchFamily="34" charset="-122"/>
                 <a:cs typeface="Calibri" pitchFamily="34" charset="-120"/>
               </a:rPr>
-              <a:t>The thread: service revenue. Write it faster, find more of it, collect it sooner.</a:t>
-            </a:r>
-            <a:endParaRPr lang="en-US" sz="1050" dirty="0"/>
-          </a:p>
+              <a:t>Reuses the Service Writer's drafting engine, so it ships fast</a:t>
+            </a:r>
+            <a:endParaRPr lang="en-US" sz="950" dirty="0"/>
+          </a:p>
+        </p:txBody>
+      </p:sp>
+      <p:sp>
+        <p:nvSpPr>
+          <p:cNvPr id="14" name="Shape 10"/>
+          <p:cNvSpPr/>
+          <p:nvPr/>
+        </p:nvSpPr>
+        <p:spPr>
+          <a:xfrm>
+            <a:off x="6035040" y="1325880"/>
+            <a:ext cx="2606040" cy="2697480"/>
+          </a:xfrm>
+          <a:prstGeom prst="roundRect">
+            <a:avLst>
+              <a:gd name="adj" fmla="val 2807"/>
+            </a:avLst>
+          </a:prstGeom>
+          <a:solidFill>
+            <a:srgbClr val="F3F6F8"/>
+          </a:solidFill>
+          <a:ln w="6350">
+            <a:solidFill>
+              <a:srgbClr val="F3F6F8"/>
+            </a:solidFill>
+            <a:prstDash val="solid"/>
+          </a:ln>
+        </p:spPr>
+      </p:sp>
+      <p:pic>
+        <p:nvPicPr>
+          <p:cNvPr id="15" name="Image 2" descr="preencoded.png">    </p:cNvPr>
+          <p:cNvPicPr>
+            <a:picLocks noChangeAspect="1"/>
+          </p:cNvPicPr>
+          <p:nvPr/>
+        </p:nvPicPr>
+        <p:blipFill>
+          <a:blip r:embed="rId3"/>
+          <a:stretch>
+            <a:fillRect/>
+          </a:stretch>
+        </p:blipFill>
+        <p:spPr>
+          <a:xfrm>
+            <a:off x="6217920" y="1463040"/>
+            <a:ext cx="411480" cy="411480"/>
+          </a:xfrm>
+          <a:prstGeom prst="rect">
+            <a:avLst/>
+          </a:prstGeom>
+        </p:spPr>
+      </p:pic>
+      <p:sp>
+        <p:nvSpPr>
+          <p:cNvPr id="16" name="Text 11"/>
+          <p:cNvSpPr txBox="1"/>
+          <p:nvPr/>
+        </p:nvSpPr>
+        <p:spPr>
+          <a:xfrm>
+            <a:off x="6720840" y="1481328"/>
+            <a:ext cx="1874520" cy="365760"/>
+          </a:xfrm>
+          <a:prstGeom prst="rect">
+            <a:avLst/>
+          </a:prstGeom>
+          <a:noFill/>
+          <a:ln/>
+        </p:spPr>
+        <p:txBody>
+          <a:bodyPr wrap="square" lIns="0" tIns="0" rIns="0" bIns="0" rtlCol="0" anchor="ctr"/>
+          <a:lstStyle/>
+          <a:p>
+            <a:pPr indent="0" marL="0">
+              <a:buNone/>
+            </a:pPr>
+            <a:r>
+              <a:rPr lang="en-US" sz="1350" b="1" dirty="0">
+                <a:solidFill>
+                  <a:srgbClr val="0B2545"/>
+                </a:solidFill>
+                <a:latin typeface="Cambria" pitchFamily="34" charset="0"/>
+                <a:ea typeface="Cambria" pitchFamily="34" charset="-122"/>
+                <a:cs typeface="Cambria" pitchFamily="34" charset="-120"/>
+              </a:rPr>
+              <a:t>3. Collections via ValPay</a:t>
+            </a:r>
+            <a:endParaRPr lang="en-US" sz="1350" dirty="0"/>
+          </a:p>
+        </p:txBody>
+      </p:sp>
+      <p:sp>
+        <p:nvSpPr>
+          <p:cNvPr id="17" name="Text 12"/>
+          <p:cNvSpPr txBox="1"/>
+          <p:nvPr/>
+        </p:nvSpPr>
+        <p:spPr>
+          <a:xfrm>
+            <a:off x="6217920" y="1965960"/>
+            <a:ext cx="2286000" cy="960120"/>
+          </a:xfrm>
+          <a:prstGeom prst="rect">
+            <a:avLst/>
+          </a:prstGeom>
+          <a:noFill/>
+          <a:ln/>
+        </p:spPr>
+        <p:txBody>
+          <a:bodyPr wrap="square" lIns="0" tIns="0" rIns="0" bIns="0" rtlCol="0" anchor="t"/>
+          <a:lstStyle/>
+          <a:p>
+            <a:pPr indent="0" marL="0">
+              <a:buNone/>
+            </a:pPr>
+            <a:r>
+              <a:rPr lang="en-US" sz="1000" dirty="0">
+                <a:solidFill>
+                  <a:srgbClr val="1B2430"/>
+                </a:solidFill>
+                <a:latin typeface="Calibri" pitchFamily="34" charset="0"/>
+                <a:ea typeface="Calibri" pitchFamily="34" charset="-122"/>
+                <a:cs typeface="Calibri" pitchFamily="34" charset="-120"/>
+              </a:rPr>
+              <a:t>Prioritises overdue accounts, drafts a reminder with tone by age and a payment link, one click to send.</a:t>
+            </a:r>
+            <a:endParaRPr lang="en-US" sz="1000" dirty="0"/>
+          </a:p>
+        </p:txBody>
+      </p:sp>
+      <p:sp>
+        <p:nvSpPr>
+          <p:cNvPr id="18" name="Text 13"/>
+          <p:cNvSpPr txBox="1"/>
+          <p:nvPr/>
+        </p:nvSpPr>
+        <p:spPr>
+          <a:xfrm>
+            <a:off x="6217920" y="2971800"/>
+            <a:ext cx="2286000" cy="1005840"/>
+          </a:xfrm>
+          <a:prstGeom prst="rect">
+            <a:avLst/>
+          </a:prstGeom>
+          <a:noFill/>
+          <a:ln/>
+        </p:spPr>
+        <p:txBody>
+          <a:bodyPr wrap="square" lIns="0" tIns="0" rIns="0" bIns="0" rtlCol="0" anchor="t"/>
+          <a:lstStyle/>
           <a:p>
             <a:pPr marL="152400" indent="-152400">
               <a:spcAft>
-                <a:spcPts val="700"/>
+                <a:spcPts val="400"/>
               </a:spcAft>
               <a:buSzPct val="100000"/>
               <a:buChar char="•"/>
             </a:pPr>
             <a:r>
-              <a:rPr lang="en-US" sz="1050" dirty="0">
+              <a:rPr lang="en-US" sz="950" dirty="0">
                 <a:solidFill>
                   <a:srgbClr val="1B2430"/>
                 </a:solidFill>
@@ -12556,15 +12992,116 @@
                 <a:ea typeface="Calibri" pitchFamily="34" charset="-122"/>
                 <a:cs typeface="Calibri" pitchFamily="34" charset="-120"/>
               </a:rPr>
-              <a:t>Not chosen: voice and scheduling already exist; slip pricing is Dockwa's ground and thin on DockMaster data.</a:t>
-            </a:r>
-            <a:endParaRPr lang="en-US" sz="1050" dirty="0"/>
-          </a:p>
-        </p:txBody>
-      </p:sp>
-      <p:sp>
-        <p:nvSpPr>
-          <p:cNvPr id="8" name="Text 5"/>
+              <a:t>Why it works: days to cash is a top GM metric</a:t>
+            </a:r>
+            <a:endParaRPr lang="en-US" sz="950" dirty="0"/>
+          </a:p>
+          <a:p>
+            <a:pPr marL="152400" indent="-152400">
+              <a:spcAft>
+                <a:spcPts val="400"/>
+              </a:spcAft>
+              <a:buSzPct val="100000"/>
+              <a:buChar char="•"/>
+            </a:pPr>
+            <a:r>
+              <a:rPr lang="en-US" sz="950" dirty="0">
+                <a:solidFill>
+                  <a:srgbClr val="1B2430"/>
+                </a:solidFill>
+                <a:latin typeface="Calibri" pitchFamily="34" charset="0"/>
+                <a:ea typeface="Calibri" pitchFamily="34" charset="-122"/>
+                <a:cs typeface="Calibri" pitchFamily="34" charset="-120"/>
+              </a:rPr>
+              <a:t>Drives ValPay attach, which subsidises the software price</a:t>
+            </a:r>
+            <a:endParaRPr lang="en-US" sz="950" dirty="0"/>
+          </a:p>
+        </p:txBody>
+      </p:sp>
+      <p:sp>
+        <p:nvSpPr>
+          <p:cNvPr id="19" name="Shape 14"/>
+          <p:cNvSpPr/>
+          <p:nvPr/>
+        </p:nvSpPr>
+        <p:spPr>
+          <a:xfrm>
+            <a:off x="457200" y="4160520"/>
+            <a:ext cx="8229600" cy="502920"/>
+          </a:xfrm>
+          <a:prstGeom prst="roundRect">
+            <a:avLst>
+              <a:gd name="adj" fmla="val 14545"/>
+            </a:avLst>
+          </a:prstGeom>
+          <a:solidFill>
+            <a:srgbClr val="F3F6F8"/>
+          </a:solidFill>
+          <a:ln w="6350">
+            <a:solidFill>
+              <a:srgbClr val="F3F6F8"/>
+            </a:solidFill>
+            <a:prstDash val="solid"/>
+          </a:ln>
+        </p:spPr>
+      </p:sp>
+      <p:sp>
+        <p:nvSpPr>
+          <p:cNvPr id="20" name="Text 15"/>
+          <p:cNvSpPr txBox="1"/>
+          <p:nvPr/>
+        </p:nvSpPr>
+        <p:spPr>
+          <a:xfrm>
+            <a:off x="640080" y="4187952"/>
+            <a:ext cx="7863840" cy="457200"/>
+          </a:xfrm>
+          <a:prstGeom prst="rect">
+            <a:avLst/>
+          </a:prstGeom>
+          <a:noFill/>
+          <a:ln/>
+        </p:spPr>
+        <p:txBody>
+          <a:bodyPr wrap="square" lIns="0" tIns="0" rIns="0" bIns="0" rtlCol="0" anchor="ctr"/>
+          <a:lstStyle/>
+          <a:p>
+            <a:pPr indent="0" marL="0">
+              <a:buNone/>
+            </a:pPr>
+            <a:r>
+              <a:rPr lang="en-US" sz="950" b="1" dirty="0">
+                <a:solidFill>
+                  <a:srgbClr val="0B2545"/>
+                </a:solidFill>
+                <a:latin typeface="Calibri" pitchFamily="34" charset="0"/>
+                <a:ea typeface="Calibri" pitchFamily="34" charset="-122"/>
+                <a:cs typeface="Calibri" pitchFamily="34" charset="-120"/>
+              </a:rPr>
+              <a:t>Also considered: </a:t>
+            </a:r>
+            <a:pPr indent="0" marL="0">
+              <a:buNone/>
+            </a:pPr>
+            <a:r>
+              <a:rPr lang="en-US" sz="950" dirty="0">
+                <a:solidFill>
+                  <a:srgbClr val="1B2430"/>
+                </a:solidFill>
+                <a:latin typeface="Calibri" pitchFamily="34" charset="0"/>
+                <a:ea typeface="Calibri" pitchFamily="34" charset="-122"/>
+                <a:cs typeface="Calibri" pitchFamily="34" charset="-120"/>
+              </a:rPr>
+              <a:t>parts demand forecasting and warranty claim assembly (good, later releases); natural-language reporting (useful, not revenue-driving); slip pricing (Dockwa's ground, thin data); boat-owner chat, voice and scheduling (already covered by Blu, the portal and the Scheduling Assistant).</a:t>
+            </a:r>
+            <a:endParaRPr lang="en-US" sz="950" dirty="0"/>
+          </a:p>
+        </p:txBody>
+      </p:sp>
+      <p:sp>
+        <p:nvSpPr>
+          <p:cNvPr id="21" name="Text 16"/>
           <p:cNvSpPr txBox="1"/>
           <p:nvPr/>
         </p:nvSpPr>
@@ -12659,7 +13196,7 @@
                 <a:ea typeface="Cambria" pitchFamily="34" charset="-122"/>
                 <a:cs typeface="Cambria" pitchFamily="34" charset="-120"/>
               </a:rPr>
-              <a:t>The Service Writer</a:t>
+              <a:t>How the Service Writer works</a:t>
             </a:r>
             <a:endParaRPr lang="en-US" sz="2800" dirty="0"/>
           </a:p>
@@ -12698,7 +13235,7 @@
                 <a:ea typeface="Calibri" pitchFamily="34" charset="-122"/>
                 <a:cs typeface="Calibri" pitchFamily="34" charset="-120"/>
               </a:rPr>
-              <a:t>From a technician's voice note to an approved work order, with a human click at every send</a:t>
+              <a:t>Product one in detail: from a technician's voice note to an approved work order, with a human click at every send</a:t>
             </a:r>
             <a:endParaRPr lang="en-US" sz="1300" dirty="0"/>
           </a:p>
@@ -13458,7 +13995,7 @@
         <p:spPr>
           <a:xfrm>
             <a:off x="457200" y="3520440"/>
-            <a:ext cx="4023360" cy="1097280"/>
+            <a:ext cx="2606040" cy="1097280"/>
           </a:xfrm>
           <a:prstGeom prst="roundRect">
             <a:avLst>
@@ -13492,8 +14029,8 @@
         </p:blipFill>
         <p:spPr>
           <a:xfrm>
-            <a:off x="594360" y="3703320"/>
-            <a:ext cx="411480" cy="411480"/>
+            <a:off x="594360" y="3657600"/>
+            <a:ext cx="365760" cy="365760"/>
           </a:xfrm>
           <a:prstGeom prst="rect">
             <a:avLst/>
@@ -13508,8 +14045,8 @@
         </p:nvSpPr>
         <p:spPr>
           <a:xfrm>
-            <a:off x="1143000" y="3611880"/>
-            <a:ext cx="3200400" cy="274320"/>
+            <a:off x="1051560" y="3611880"/>
+            <a:ext cx="1920240" cy="274320"/>
           </a:xfrm>
           <a:prstGeom prst="rect">
             <a:avLst/>
@@ -13525,7 +14062,7 @@
               <a:buNone/>
             </a:pPr>
             <a:r>
-              <a:rPr lang="en-US" sz="1250" b="1" dirty="0">
+              <a:rPr lang="en-US" sz="1150" b="1" dirty="0">
                 <a:solidFill>
                   <a:srgbClr val="0B2545"/>
                 </a:solidFill>
@@ -13533,9 +14070,9 @@
                 <a:ea typeface="Cambria" pitchFamily="34" charset="-122"/>
                 <a:cs typeface="Cambria" pitchFamily="34" charset="-120"/>
               </a:rPr>
-              <a:t>Release 2: proactive demand</a:t>
-            </a:r>
-            <a:endParaRPr lang="en-US" sz="1250" dirty="0"/>
+              <a:t>Selects, never invents</a:t>
+            </a:r>
+            <a:endParaRPr lang="en-US" sz="1150" dirty="0"/>
           </a:p>
         </p:txBody>
       </p:sp>
@@ -13547,8 +14084,8 @@
         </p:nvSpPr>
         <p:spPr>
           <a:xfrm>
-            <a:off x="1143000" y="3904488"/>
-            <a:ext cx="3200400" cy="640080"/>
+            <a:off x="594360" y="4041648"/>
+            <a:ext cx="2331720" cy="548640"/>
           </a:xfrm>
           <a:prstGeom prst="rect">
             <a:avLst/>
@@ -13564,7 +14101,7 @@
               <a:buNone/>
             </a:pPr>
             <a:r>
-              <a:rPr lang="en-US" sz="1000" dirty="0">
+              <a:rPr lang="en-US" sz="900" dirty="0">
                 <a:solidFill>
                   <a:srgbClr val="1B2430"/>
                 </a:solidFill>
@@ -13572,9 +14109,9 @@
                 <a:ea typeface="Calibri" pitchFamily="34" charset="-122"/>
                 <a:cs typeface="Calibri" pitchFamily="34" charset="-120"/>
               </a:rPr>
-              <a:t>Per-vessel interval predictions produce a draft estimate and a short outreach message before the season starts.</a:t>
-            </a:r>
-            <a:endParaRPr lang="en-US" sz="1000" dirty="0"/>
+              <a:t>Operation codes, parts, prices and vessels come from the database. The model picks and explains.</a:t>
+            </a:r>
+            <a:endParaRPr lang="en-US" sz="900" dirty="0"/>
           </a:p>
         </p:txBody>
       </p:sp>
@@ -13586,8 +14123,8 @@
         </p:nvSpPr>
         <p:spPr>
           <a:xfrm>
-            <a:off x="4663440" y="3520440"/>
-            <a:ext cx="4023360" cy="1097280"/>
+            <a:off x="3246120" y="3520440"/>
+            <a:ext cx="2606040" cy="1097280"/>
           </a:xfrm>
           <a:prstGeom prst="roundRect">
             <a:avLst>
@@ -13621,8 +14158,8 @@
         </p:blipFill>
         <p:spPr>
           <a:xfrm>
-            <a:off x="4800600" y="3703320"/>
-            <a:ext cx="411480" cy="411480"/>
+            <a:off x="3383280" y="3657600"/>
+            <a:ext cx="365760" cy="365760"/>
           </a:xfrm>
           <a:prstGeom prst="rect">
             <a:avLst/>
@@ -13637,8 +14174,8 @@
         </p:nvSpPr>
         <p:spPr>
           <a:xfrm>
-            <a:off x="5349240" y="3611880"/>
-            <a:ext cx="3200400" cy="274320"/>
+            <a:off x="3840480" y="3611880"/>
+            <a:ext cx="1920240" cy="274320"/>
           </a:xfrm>
           <a:prstGeom prst="rect">
             <a:avLst/>
@@ -13654,7 +14191,7 @@
               <a:buNone/>
             </a:pPr>
             <a:r>
-              <a:rPr lang="en-US" sz="1250" b="1" dirty="0">
+              <a:rPr lang="en-US" sz="1150" b="1" dirty="0">
                 <a:solidFill>
                   <a:srgbClr val="0B2545"/>
                 </a:solidFill>
@@ -13662,9 +14199,9 @@
                 <a:ea typeface="Cambria" pitchFamily="34" charset="-122"/>
                 <a:cs typeface="Cambria" pitchFamily="34" charset="-120"/>
               </a:rPr>
-              <a:t>Release 3: collections via ValPay</a:t>
-            </a:r>
-            <a:endParaRPr lang="en-US" sz="1250" dirty="0"/>
+              <a:t>Human at every send</a:t>
+            </a:r>
+            <a:endParaRPr lang="en-US" sz="1150" dirty="0"/>
           </a:p>
         </p:txBody>
       </p:sp>
@@ -13676,8 +14213,8 @@
         </p:nvSpPr>
         <p:spPr>
           <a:xfrm>
-            <a:off x="5349240" y="3904488"/>
-            <a:ext cx="3200400" cy="640080"/>
+            <a:off x="3383280" y="4041648"/>
+            <a:ext cx="2331720" cy="548640"/>
           </a:xfrm>
           <a:prstGeom prst="rect">
             <a:avLst/>
@@ -13693,7 +14230,7 @@
               <a:buNone/>
             </a:pPr>
             <a:r>
-              <a:rPr lang="en-US" sz="1000" dirty="0">
+              <a:rPr lang="en-US" sz="900" dirty="0">
                 <a:solidFill>
                   <a:srgbClr val="1B2430"/>
                 </a:solidFill>
@@ -13701,15 +14238,144 @@
                 <a:ea typeface="Calibri" pitchFamily="34" charset="-122"/>
                 <a:cs typeface="Calibri" pitchFamily="34" charset="-120"/>
               </a:rPr>
-              <a:t>Overdue accounts get a drafted reminder and a payment link, tone by age, one click to send.</a:t>
-            </a:r>
-            <a:endParaRPr lang="en-US" sz="1000" dirty="0"/>
-          </a:p>
-        </p:txBody>
-      </p:sp>
-      <p:sp>
-        <p:nvSpPr>
-          <p:cNvPr id="36" name="Text 27"/>
+              <a:t>Confidence per line; low-confidence lines excluded by default; no message leaves without a staff click.</a:t>
+            </a:r>
+            <a:endParaRPr lang="en-US" sz="900" dirty="0"/>
+          </a:p>
+        </p:txBody>
+      </p:sp>
+      <p:sp>
+        <p:nvSpPr>
+          <p:cNvPr id="36" name="Shape 27"/>
+          <p:cNvSpPr/>
+          <p:nvPr/>
+        </p:nvSpPr>
+        <p:spPr>
+          <a:xfrm>
+            <a:off x="6035040" y="3520440"/>
+            <a:ext cx="2606040" cy="1097280"/>
+          </a:xfrm>
+          <a:prstGeom prst="roundRect">
+            <a:avLst>
+              <a:gd name="adj" fmla="val 6667"/>
+            </a:avLst>
+          </a:prstGeom>
+          <a:solidFill>
+            <a:srgbClr val="E3F5F3"/>
+          </a:solidFill>
+          <a:ln w="6350">
+            <a:solidFill>
+              <a:srgbClr val="E3F5F3"/>
+            </a:solidFill>
+            <a:prstDash val="solid"/>
+          </a:ln>
+        </p:spPr>
+      </p:sp>
+      <p:pic>
+        <p:nvPicPr>
+          <p:cNvPr id="37" name="Image 7" descr="preencoded.png">    </p:cNvPr>
+          <p:cNvPicPr>
+            <a:picLocks noChangeAspect="1"/>
+          </p:cNvPicPr>
+          <p:nvPr/>
+        </p:nvPicPr>
+        <p:blipFill>
+          <a:blip r:embed="rId8"/>
+          <a:stretch>
+            <a:fillRect/>
+          </a:stretch>
+        </p:blipFill>
+        <p:spPr>
+          <a:xfrm>
+            <a:off x="6172200" y="3657600"/>
+            <a:ext cx="365760" cy="365760"/>
+          </a:xfrm>
+          <a:prstGeom prst="rect">
+            <a:avLst/>
+          </a:prstGeom>
+        </p:spPr>
+      </p:pic>
+      <p:sp>
+        <p:nvSpPr>
+          <p:cNvPr id="38" name="Text 28"/>
+          <p:cNvSpPr txBox="1"/>
+          <p:nvPr/>
+        </p:nvSpPr>
+        <p:spPr>
+          <a:xfrm>
+            <a:off x="6629400" y="3611880"/>
+            <a:ext cx="1920240" cy="274320"/>
+          </a:xfrm>
+          <a:prstGeom prst="rect">
+            <a:avLst/>
+          </a:prstGeom>
+          <a:noFill/>
+          <a:ln/>
+        </p:spPr>
+        <p:txBody>
+          <a:bodyPr wrap="square" lIns="0" tIns="0" rIns="0" bIns="0" rtlCol="0" anchor="ctr"/>
+          <a:lstStyle/>
+          <a:p>
+            <a:pPr indent="0" marL="0">
+              <a:buNone/>
+            </a:pPr>
+            <a:r>
+              <a:rPr lang="en-US" sz="1150" b="1" dirty="0">
+                <a:solidFill>
+                  <a:srgbClr val="0B2545"/>
+                </a:solidFill>
+                <a:latin typeface="Cambria" pitchFamily="34" charset="0"/>
+                <a:ea typeface="Cambria" pitchFamily="34" charset="-122"/>
+                <a:cs typeface="Cambria" pitchFamily="34" charset="-120"/>
+              </a:rPr>
+              <a:t>Scoped and audited</a:t>
+            </a:r>
+            <a:endParaRPr lang="en-US" sz="1150" dirty="0"/>
+          </a:p>
+        </p:txBody>
+      </p:sp>
+      <p:sp>
+        <p:nvSpPr>
+          <p:cNvPr id="39" name="Text 29"/>
+          <p:cNvSpPr txBox="1"/>
+          <p:nvPr/>
+        </p:nvSpPr>
+        <p:spPr>
+          <a:xfrm>
+            <a:off x="6172200" y="4041648"/>
+            <a:ext cx="2331720" cy="548640"/>
+          </a:xfrm>
+          <a:prstGeom prst="rect">
+            <a:avLst/>
+          </a:prstGeom>
+          <a:noFill/>
+          <a:ln/>
+        </p:spPr>
+        <p:txBody>
+          <a:bodyPr wrap="square" lIns="0" tIns="0" rIns="0" bIns="0" rtlCol="0" anchor="t"/>
+          <a:lstStyle/>
+          <a:p>
+            <a:pPr indent="0" marL="0">
+              <a:buNone/>
+            </a:pPr>
+            <a:r>
+              <a:rPr lang="en-US" sz="900" dirty="0">
+                <a:solidFill>
+                  <a:srgbClr val="1B2430"/>
+                </a:solidFill>
+                <a:latin typeface="Calibri" pitchFamily="34" charset="0"/>
+                <a:ea typeface="Calibri" pitchFamily="34" charset="-122"/>
+                <a:cs typeface="Calibri" pitchFamily="34" charset="-120"/>
+              </a:rPr>
+              <a:t>Allowed codes per role, manager approval above a threshold, full activity log, mirroring Blu's controls.</a:t>
+            </a:r>
+            <a:endParaRPr lang="en-US" sz="900" dirty="0"/>
+          </a:p>
+        </p:txBody>
+      </p:sp>
+      <p:sp>
+        <p:nvSpPr>
+          <p:cNvPr id="40" name="Text 30"/>
           <p:cNvSpPr txBox="1"/>
           <p:nvPr/>
         </p:nvSpPr>
@@ -13804,7 +14470,7 @@
                 <a:ea typeface="Cambria" pitchFamily="34" charset="-122"/>
                 <a:cs typeface="Cambria" pitchFamily="34" charset="-120"/>
               </a:rPr>
-              <a:t>Why this opportunity</a:t>
+              <a:t>Why this is the right bet for DockMaster and Valsoft</a:t>
             </a:r>
             <a:endParaRPr lang="en-US" sz="2800" dirty="0"/>
           </a:p>
@@ -13843,7 +14509,7 @@
                 <a:ea typeface="Calibri" pitchFamily="34" charset="-122"/>
                 <a:cs typeface="Calibri" pitchFamily="34" charset="-120"/>
               </a:rPr>
-              <a:t>Five reasons, in the order a marina GM and a Valsoft operator would rank them</a:t>
+              <a:t>Beyond the customer ROI: what the business gets</a:t>
             </a:r>
             <a:endParaRPr lang="en-US" sz="1300" dirty="0"/>
           </a:p>
@@ -13906,7 +14572,7 @@
                 <a:ea typeface="Cambria" pitchFamily="34" charset="-122"/>
                 <a:cs typeface="Cambria" pitchFamily="34" charset="-120"/>
               </a:rPr>
-              <a:t>Measurable ROI</a:t>
+              <a:t>Built on the moat</a:t>
             </a:r>
             <a:endParaRPr lang="en-US" sz="1400" dirty="0"/>
           </a:p>
@@ -13945,7 +14611,7 @@
                 <a:ea typeface="Calibri" pitchFamily="34" charset="-122"/>
                 <a:cs typeface="Calibri" pitchFamily="34" charset="-120"/>
               </a:rPr>
-              <a:t>Estimate turnaround, approval rate, billed vs standard hours, unbilled work, days to invoice. Units the GM already tracks.</a:t>
+              <a:t>Competitors can copy a chatbot. They cannot copy decades of operation codes, labour standards and vessel histories.</a:t>
             </a:r>
             <a:endParaRPr lang="en-US" sz="1100" dirty="0"/>
           </a:p>
@@ -14031,7 +14697,7 @@
                 <a:ea typeface="Cambria" pitchFamily="34" charset="-122"/>
                 <a:cs typeface="Cambria" pitchFamily="34" charset="-120"/>
               </a:rPr>
-              <a:t>Built on the moat</a:t>
+              <a:t>Compounds existing AI</a:t>
             </a:r>
             <a:endParaRPr lang="en-US" sz="1400" dirty="0"/>
           </a:p>
@@ -14070,7 +14736,7 @@
                 <a:ea typeface="Calibri" pitchFamily="34" charset="-122"/>
                 <a:cs typeface="Calibri" pitchFamily="34" charset="-120"/>
               </a:rPr>
-              <a:t>Every input exists today: voice notes, photos, operation codes, labour standards, parts, vessel history, eSign. Nothing new to capture.</a:t>
+              <a:t>Blu takes the call, scheduling assigns the tech, the Service Writer turns the job into revenue. One story, three features.</a:t>
             </a:r>
             <a:endParaRPr lang="en-US" sz="1100" dirty="0"/>
           </a:p>
@@ -14156,7 +14822,7 @@
                 <a:ea typeface="Cambria" pitchFamily="34" charset="-122"/>
                 <a:cs typeface="Cambria" pitchFamily="34" charset="-120"/>
               </a:rPr>
-              <a:t>Compounds existing AI</a:t>
+              <a:t>Drives Web migration</a:t>
             </a:r>
             <a:endParaRPr lang="en-US" sz="1400" dirty="0"/>
           </a:p>
@@ -14195,7 +14861,7 @@
                 <a:ea typeface="Calibri" pitchFamily="34" charset="-122"/>
                 <a:cs typeface="Calibri" pitchFamily="34" charset="-120"/>
               </a:rPr>
-              <a:t>Blu takes the call, scheduling assigns the tech, the Service Writer turns the job into revenue.</a:t>
+              <a:t>It needs Web 2.0 and Mobile, which gives Desktop-only accounts a revenue reason to move and answers the UX critique.</a:t>
             </a:r>
             <a:endParaRPr lang="en-US" sz="1100" dirty="0"/>
           </a:p>
@@ -14281,7 +14947,7 @@
                 <a:ea typeface="Cambria" pitchFamily="34" charset="-122"/>
                 <a:cs typeface="Cambria" pitchFamily="34" charset="-120"/>
               </a:rPr>
-              <a:t>Lands with a conservative base</a:t>
+              <a:t>Drives payments attach</a:t>
             </a:r>
             <a:endParaRPr lang="en-US" sz="1400" dirty="0"/>
           </a:p>
@@ -14320,7 +14986,7 @@
                 <a:ea typeface="Calibri" pitchFamily="34" charset="-122"/>
                 <a:cs typeface="Calibri" pitchFamily="34" charset="-120"/>
               </a:rPr>
-              <a:t>Follows DockMaster's own principle: the AI assists, staff stays in control.</a:t>
+              <a:t>Collections via ValPay lifts volume on Valsoft's own rails; margin there subsidises the software price.</a:t>
             </a:r>
             <a:endParaRPr lang="en-US" sz="1100" dirty="0"/>
           </a:p>
@@ -14445,7 +15111,7 @@
                 <a:ea typeface="Calibri" pitchFamily="34" charset="-122"/>
                 <a:cs typeface="Calibri" pitchFamily="34" charset="-120"/>
               </a:rPr>
-              <a:t>Validate on 1,000+ accounts, drive Web migration and ValPay attach, then take a standalone product beyond the ecosystem via AI Ventures.</a:t>
+              <a:t>Human-in-the-loop lands with a conservative base. Validate on 1,000+ accounts, then take a standalone product beyond the ecosystem via AI Ventures.</a:t>
             </a:r>
             <a:endParaRPr lang="en-US" sz="1100" dirty="0"/>
           </a:p>
@@ -14780,7 +15446,7 @@
                 <a:ea typeface="Calibri" pitchFamily="34" charset="-122"/>
                 <a:cs typeface="Calibri" pitchFamily="34" charset="-120"/>
               </a:rPr>
-              <a:t>Side panels: vessels due for service and overdue AR with one-click reminders.</a:t>
+              <a:t>Side panels: vessels due for service and overdue AR with one-click reminders (products two and three).</a:t>
             </a:r>
             <a:endParaRPr lang="en-US" sz="1050" dirty="0"/>
           </a:p>
@@ -14976,7 +15642,7 @@
                 <a:ea typeface="Cambria" pitchFamily="34" charset="-122"/>
                 <a:cs typeface="Cambria" pitchFamily="34" charset="-120"/>
               </a:rPr>
-              <a:t>Guardrails and evaluation</a:t>
+              <a:t>Evaluation</a:t>
             </a:r>
             <a:endParaRPr lang="en-US" sz="1500" dirty="0"/>
           </a:p>
@@ -15019,7 +15685,7 @@
                 <a:ea typeface="Calibri" pitchFamily="34" charset="-122"/>
                 <a:cs typeface="Calibri" pitchFamily="34" charset="-120"/>
               </a:rPr>
-              <a:t>Model only selects from DB candidates; confidence badge per line; low-confidence lines excluded by default</a:t>
+              <a:t>15-case golden set: clear notes, slang, ambiguous vessel hints, multi-system jobs, one note with nothing actionable</a:t>
             </a:r>
             <a:endParaRPr lang="en-US" sz="1000" dirty="0"/>
           </a:p>
@@ -15040,7 +15706,7 @@
                 <a:ea typeface="Calibri" pitchFamily="34" charset="-122"/>
                 <a:cs typeface="Calibri" pitchFamily="34" charset="-120"/>
               </a:rPr>
-              <a:t>No send without a staff click; scoped codes per role; audit trail on every action</a:t>
+              <a:t>Targets: vessel match 14/15, operation recall 85%+, separate-estimate detection correct</a:t>
             </a:r>
             <a:endParaRPr lang="en-US" sz="1000" dirty="0"/>
           </a:p>
@@ -15061,7 +15727,7 @@
                 <a:ea typeface="Calibri" pitchFamily="34" charset="-122"/>
                 <a:cs typeface="Calibri" pitchFamily="34" charset="-120"/>
               </a:rPr>
-              <a:t>15-case golden set. Targets: vessel match 14/15, operation recall 85%+</a:t>
+              <a:t>Guardrails from the previous slide are implemented in code, not just described</a:t>
             </a:r>
             <a:endParaRPr lang="en-US" sz="1000" dirty="0"/>
           </a:p>

</xml_diff>